<commit_message>
feat(logs): 방문 기록 전용 CSV export (visit_histories 기반)
봉사 로그(감사 로그)는 정기방문/식당 미기록·토큰없음 스킵·역할필터로
누락될 수 있음. visit_histories 기반의 완전한 방문 기록 CSV 추가.
- utils/visitRecordsCsv: unitId→건물/세대, cardId→카드/구 enrich
  컬럼: 방문일·시간대·구·카드·건물·세대·방문자·결과·유형·메모
- 봉사 로그 화면에 '방문 기록 CSV' 버튼 추가 (기존은 '봉사 로그 CSV')
- visitHistories/buildings 를 ServiceLogPage 로 연결

Co-Authored-By: Claude Opus 4.8 <noreply@anthropic.com>
</commit_message>
<xml_diff>
--- a/docs/应用使用说明-传道员-带头人.pptx
+++ b/docs/应用使用说明-传道员-带头人.pptx
@@ -4,28 +4,31 @@
   <p:sldMasterIdLst>
     <p:sldMasterId id="2147483648" r:id="rId1"/>
   </p:sldMasterIdLst>
+  <p:notesMasterIdLst>
+    <p:notesMasterId r:id="rId21"/>
+  </p:notesMasterIdLst>
   <p:sldIdLst>
-    <p:sldId id="256" r:id="rId7"/>
-    <p:sldId id="257" r:id="rId8"/>
-    <p:sldId id="258" r:id="rId9"/>
-    <p:sldId id="259" r:id="rId10"/>
-    <p:sldId id="260" r:id="rId11"/>
-    <p:sldId id="261" r:id="rId12"/>
-    <p:sldId id="262" r:id="rId13"/>
-    <p:sldId id="263" r:id="rId14"/>
-    <p:sldId id="264" r:id="rId15"/>
-    <p:sldId id="265" r:id="rId16"/>
-    <p:sldId id="266" r:id="rId17"/>
-    <p:sldId id="267" r:id="rId18"/>
-    <p:sldId id="268" r:id="rId19"/>
-    <p:sldId id="269" r:id="rId20"/>
-    <p:sldId id="270" r:id="rId21"/>
-    <p:sldId id="271" r:id="rId22"/>
-    <p:sldId id="272" r:id="rId23"/>
-    <p:sldId id="273" r:id="rId24"/>
-    <p:sldId id="274" r:id="rId25"/>
+    <p:sldId id="256" r:id="rId2"/>
+    <p:sldId id="257" r:id="rId3"/>
+    <p:sldId id="258" r:id="rId4"/>
+    <p:sldId id="259" r:id="rId5"/>
+    <p:sldId id="260" r:id="rId6"/>
+    <p:sldId id="261" r:id="rId7"/>
+    <p:sldId id="262" r:id="rId8"/>
+    <p:sldId id="263" r:id="rId9"/>
+    <p:sldId id="264" r:id="rId10"/>
+    <p:sldId id="265" r:id="rId11"/>
+    <p:sldId id="266" r:id="rId12"/>
+    <p:sldId id="267" r:id="rId13"/>
+    <p:sldId id="268" r:id="rId14"/>
+    <p:sldId id="269" r:id="rId15"/>
+    <p:sldId id="270" r:id="rId16"/>
+    <p:sldId id="271" r:id="rId17"/>
+    <p:sldId id="272" r:id="rId18"/>
+    <p:sldId id="273" r:id="rId19"/>
+    <p:sldId id="274" r:id="rId20"/>
   </p:sldIdLst>
-  <p:sldSz cx="12191695" cy="6858000" type="screen4x3"/>
+  <p:sldSz cx="12192000" cy="6858000"/>
   <p:notesSz cx="6858000" cy="9144000"/>
   <p:defaultTextStyle>
     <a:defPPr>
@@ -122,7 +125,457 @@
       </a:defRPr>
     </a:lvl9pPr>
   </p:defaultTextStyle>
+  <p:extLst>
+    <p:ext uri="{EFAFB233-063F-42B5-8137-9DF3F51BA10A}">
+      <p15:sldGuideLst xmlns:p15="http://schemas.microsoft.com/office/powerpoint/2012/main">
+        <p15:guide id="1" orient="horz" pos="2160">
+          <p15:clr>
+            <a:srgbClr val="A4A3A4"/>
+          </p15:clr>
+        </p15:guide>
+        <p15:guide id="2" pos="2880">
+          <p15:clr>
+            <a:srgbClr val="A4A3A4"/>
+          </p15:clr>
+        </p15:guide>
+      </p15:sldGuideLst>
+    </p:ext>
+  </p:extLst>
 </p:presentation>
+</file>
+
+<file path=ppt/notesMasters/notesMaster1.xml><?xml version="1.0" encoding="utf-8"?>
+<p:notesMaster xmlns:a="http://schemas.openxmlformats.org/drawingml/2006/main" xmlns:r="http://schemas.openxmlformats.org/officeDocument/2006/relationships" xmlns:p="http://schemas.openxmlformats.org/presentationml/2006/main">
+  <p:cSld>
+    <p:bg>
+      <p:bgRef idx="1001">
+        <a:schemeClr val="bg1"/>
+      </p:bgRef>
+    </p:bg>
+    <p:spTree>
+      <p:nvGrpSpPr>
+        <p:cNvPr id="1" name=""/>
+        <p:cNvGrpSpPr/>
+        <p:nvPr/>
+      </p:nvGrpSpPr>
+      <p:grpSpPr>
+        <a:xfrm>
+          <a:off x="0" y="0"/>
+          <a:ext cx="0" cy="0"/>
+          <a:chOff x="0" y="0"/>
+          <a:chExt cx="0" cy="0"/>
+        </a:xfrm>
+      </p:grpSpPr>
+      <p:sp>
+        <p:nvSpPr>
+          <p:cNvPr id="2" name="머리글 개체 틀 1"/>
+          <p:cNvSpPr>
+            <a:spLocks noGrp="1"/>
+          </p:cNvSpPr>
+          <p:nvPr>
+            <p:ph type="hdr" sz="quarter"/>
+          </p:nvPr>
+        </p:nvSpPr>
+        <p:spPr>
+          <a:xfrm>
+            <a:off x="0" y="0"/>
+            <a:ext cx="2971800" cy="458788"/>
+          </a:xfrm>
+          <a:prstGeom prst="rect">
+            <a:avLst/>
+          </a:prstGeom>
+        </p:spPr>
+        <p:txBody>
+          <a:bodyPr vert="horz" lIns="91440" tIns="45720" rIns="91440" bIns="45720" rtlCol="0"/>
+          <a:lstStyle>
+            <a:lvl1pPr algn="l">
+              <a:defRPr sz="1200"/>
+            </a:lvl1pPr>
+          </a:lstStyle>
+          <a:p>
+            <a:endParaRPr kumimoji="1" lang="ko-Kore-KR" altLang="en-US"/>
+          </a:p>
+        </p:txBody>
+      </p:sp>
+      <p:sp>
+        <p:nvSpPr>
+          <p:cNvPr id="3" name="날짜 개체 틀 2"/>
+          <p:cNvSpPr>
+            <a:spLocks noGrp="1"/>
+          </p:cNvSpPr>
+          <p:nvPr>
+            <p:ph type="dt" idx="1"/>
+          </p:nvPr>
+        </p:nvSpPr>
+        <p:spPr>
+          <a:xfrm>
+            <a:off x="3884613" y="0"/>
+            <a:ext cx="2971800" cy="458788"/>
+          </a:xfrm>
+          <a:prstGeom prst="rect">
+            <a:avLst/>
+          </a:prstGeom>
+        </p:spPr>
+        <p:txBody>
+          <a:bodyPr vert="horz" lIns="91440" tIns="45720" rIns="91440" bIns="45720" rtlCol="0"/>
+          <a:lstStyle>
+            <a:lvl1pPr algn="r">
+              <a:defRPr sz="1200"/>
+            </a:lvl1pPr>
+          </a:lstStyle>
+          <a:p>
+            <a:fld id="{6F1D1CEA-40B1-5D4C-B1D4-6FC35707DDEB}" type="datetimeFigureOut">
+              <a:rPr kumimoji="1" lang="ko-Kore-KR" altLang="en-US" smtClean="0"/>
+              <a:t>2026. 6. 27.</a:t>
+            </a:fld>
+            <a:endParaRPr kumimoji="1" lang="ko-Kore-KR" altLang="en-US"/>
+          </a:p>
+        </p:txBody>
+      </p:sp>
+      <p:sp>
+        <p:nvSpPr>
+          <p:cNvPr id="4" name="슬라이드 이미지 개체 틀 3"/>
+          <p:cNvSpPr>
+            <a:spLocks noGrp="1" noRot="1" noChangeAspect="1"/>
+          </p:cNvSpPr>
+          <p:nvPr>
+            <p:ph type="sldImg" idx="2"/>
+          </p:nvPr>
+        </p:nvSpPr>
+        <p:spPr>
+          <a:xfrm>
+            <a:off x="685800" y="1143000"/>
+            <a:ext cx="5486400" cy="3086100"/>
+          </a:xfrm>
+          <a:prstGeom prst="rect">
+            <a:avLst/>
+          </a:prstGeom>
+          <a:noFill/>
+          <a:ln w="12700">
+            <a:solidFill>
+              <a:prstClr val="black"/>
+            </a:solidFill>
+          </a:ln>
+        </p:spPr>
+        <p:txBody>
+          <a:bodyPr vert="horz" lIns="91440" tIns="45720" rIns="91440" bIns="45720" rtlCol="0" anchor="ctr"/>
+          <a:lstStyle/>
+          <a:p>
+            <a:endParaRPr lang="ko-Kore-KR" altLang="en-US"/>
+          </a:p>
+        </p:txBody>
+      </p:sp>
+      <p:sp>
+        <p:nvSpPr>
+          <p:cNvPr id="5" name="슬라이드 노트 개체 틀 4"/>
+          <p:cNvSpPr>
+            <a:spLocks noGrp="1"/>
+          </p:cNvSpPr>
+          <p:nvPr>
+            <p:ph type="body" sz="quarter" idx="3"/>
+          </p:nvPr>
+        </p:nvSpPr>
+        <p:spPr>
+          <a:xfrm>
+            <a:off x="685800" y="4400550"/>
+            <a:ext cx="5486400" cy="3600450"/>
+          </a:xfrm>
+          <a:prstGeom prst="rect">
+            <a:avLst/>
+          </a:prstGeom>
+        </p:spPr>
+        <p:txBody>
+          <a:bodyPr vert="horz" lIns="91440" tIns="45720" rIns="91440" bIns="45720" rtlCol="0"/>
+          <a:lstStyle/>
+          <a:p>
+            <a:pPr lvl="0"/>
+            <a:r>
+              <a:rPr kumimoji="1" lang="ko-KR" altLang="en-US"/>
+              <a:t>마스터 텍스트 스타일을 편집하려면 클릭</a:t>
+            </a:r>
+          </a:p>
+          <a:p>
+            <a:pPr lvl="1"/>
+            <a:r>
+              <a:rPr kumimoji="1" lang="ko-KR" altLang="en-US"/>
+              <a:t>두 번째 수준</a:t>
+            </a:r>
+          </a:p>
+          <a:p>
+            <a:pPr lvl="2"/>
+            <a:r>
+              <a:rPr kumimoji="1" lang="ko-KR" altLang="en-US"/>
+              <a:t>세 번째 수준</a:t>
+            </a:r>
+          </a:p>
+          <a:p>
+            <a:pPr lvl="3"/>
+            <a:r>
+              <a:rPr kumimoji="1" lang="ko-KR" altLang="en-US"/>
+              <a:t>네 번째 수준</a:t>
+            </a:r>
+          </a:p>
+          <a:p>
+            <a:pPr lvl="4"/>
+            <a:r>
+              <a:rPr kumimoji="1" lang="ko-KR" altLang="en-US"/>
+              <a:t>다섯 번째 수준</a:t>
+            </a:r>
+            <a:endParaRPr kumimoji="1" lang="ko-Kore-KR" altLang="en-US"/>
+          </a:p>
+        </p:txBody>
+      </p:sp>
+      <p:sp>
+        <p:nvSpPr>
+          <p:cNvPr id="6" name="바닥글 개체 틀 5"/>
+          <p:cNvSpPr>
+            <a:spLocks noGrp="1"/>
+          </p:cNvSpPr>
+          <p:nvPr>
+            <p:ph type="ftr" sz="quarter" idx="4"/>
+          </p:nvPr>
+        </p:nvSpPr>
+        <p:spPr>
+          <a:xfrm>
+            <a:off x="0" y="8685213"/>
+            <a:ext cx="2971800" cy="458787"/>
+          </a:xfrm>
+          <a:prstGeom prst="rect">
+            <a:avLst/>
+          </a:prstGeom>
+        </p:spPr>
+        <p:txBody>
+          <a:bodyPr vert="horz" lIns="91440" tIns="45720" rIns="91440" bIns="45720" rtlCol="0" anchor="b"/>
+          <a:lstStyle>
+            <a:lvl1pPr algn="l">
+              <a:defRPr sz="1200"/>
+            </a:lvl1pPr>
+          </a:lstStyle>
+          <a:p>
+            <a:endParaRPr kumimoji="1" lang="ko-Kore-KR" altLang="en-US"/>
+          </a:p>
+        </p:txBody>
+      </p:sp>
+      <p:sp>
+        <p:nvSpPr>
+          <p:cNvPr id="7" name="슬라이드 번호 개체 틀 6"/>
+          <p:cNvSpPr>
+            <a:spLocks noGrp="1"/>
+          </p:cNvSpPr>
+          <p:nvPr>
+            <p:ph type="sldNum" sz="quarter" idx="5"/>
+          </p:nvPr>
+        </p:nvSpPr>
+        <p:spPr>
+          <a:xfrm>
+            <a:off x="3884613" y="8685213"/>
+            <a:ext cx="2971800" cy="458787"/>
+          </a:xfrm>
+          <a:prstGeom prst="rect">
+            <a:avLst/>
+          </a:prstGeom>
+        </p:spPr>
+        <p:txBody>
+          <a:bodyPr vert="horz" lIns="91440" tIns="45720" rIns="91440" bIns="45720" rtlCol="0" anchor="b"/>
+          <a:lstStyle>
+            <a:lvl1pPr algn="r">
+              <a:defRPr sz="1200"/>
+            </a:lvl1pPr>
+          </a:lstStyle>
+          <a:p>
+            <a:fld id="{7B3DB1E6-C265-D44D-9017-6CAC397A47BB}" type="slidenum">
+              <a:rPr kumimoji="1" lang="ko-Kore-KR" altLang="en-US" smtClean="0"/>
+              <a:t>‹#›</a:t>
+            </a:fld>
+            <a:endParaRPr kumimoji="1" lang="ko-Kore-KR" altLang="en-US"/>
+          </a:p>
+        </p:txBody>
+      </p:sp>
+    </p:spTree>
+    <p:extLst>
+      <p:ext uri="{BB962C8B-B14F-4D97-AF65-F5344CB8AC3E}">
+        <p14:creationId xmlns:p14="http://schemas.microsoft.com/office/powerpoint/2010/main" val="2747009727"/>
+      </p:ext>
+    </p:extLst>
+  </p:cSld>
+  <p:clrMap bg1="lt1" tx1="dk1" bg2="lt2" tx2="dk2" accent1="accent1" accent2="accent2" accent3="accent3" accent4="accent4" accent5="accent5" accent6="accent6" hlink="hlink" folHlink="folHlink"/>
+  <p:notesStyle>
+    <a:lvl1pPr marL="0" algn="l" defTabSz="914400" rtl="0" eaLnBrk="1" latinLnBrk="0" hangingPunct="1">
+      <a:defRPr sz="1200" kern="1200">
+        <a:solidFill>
+          <a:schemeClr val="tx1"/>
+        </a:solidFill>
+        <a:latin typeface="+mn-lt"/>
+        <a:ea typeface="+mn-ea"/>
+        <a:cs typeface="+mn-cs"/>
+      </a:defRPr>
+    </a:lvl1pPr>
+    <a:lvl2pPr marL="457200" algn="l" defTabSz="914400" rtl="0" eaLnBrk="1" latinLnBrk="0" hangingPunct="1">
+      <a:defRPr sz="1200" kern="1200">
+        <a:solidFill>
+          <a:schemeClr val="tx1"/>
+        </a:solidFill>
+        <a:latin typeface="+mn-lt"/>
+        <a:ea typeface="+mn-ea"/>
+        <a:cs typeface="+mn-cs"/>
+      </a:defRPr>
+    </a:lvl2pPr>
+    <a:lvl3pPr marL="914400" algn="l" defTabSz="914400" rtl="0" eaLnBrk="1" latinLnBrk="0" hangingPunct="1">
+      <a:defRPr sz="1200" kern="1200">
+        <a:solidFill>
+          <a:schemeClr val="tx1"/>
+        </a:solidFill>
+        <a:latin typeface="+mn-lt"/>
+        <a:ea typeface="+mn-ea"/>
+        <a:cs typeface="+mn-cs"/>
+      </a:defRPr>
+    </a:lvl3pPr>
+    <a:lvl4pPr marL="1371600" algn="l" defTabSz="914400" rtl="0" eaLnBrk="1" latinLnBrk="0" hangingPunct="1">
+      <a:defRPr sz="1200" kern="1200">
+        <a:solidFill>
+          <a:schemeClr val="tx1"/>
+        </a:solidFill>
+        <a:latin typeface="+mn-lt"/>
+        <a:ea typeface="+mn-ea"/>
+        <a:cs typeface="+mn-cs"/>
+      </a:defRPr>
+    </a:lvl4pPr>
+    <a:lvl5pPr marL="1828800" algn="l" defTabSz="914400" rtl="0" eaLnBrk="1" latinLnBrk="0" hangingPunct="1">
+      <a:defRPr sz="1200" kern="1200">
+        <a:solidFill>
+          <a:schemeClr val="tx1"/>
+        </a:solidFill>
+        <a:latin typeface="+mn-lt"/>
+        <a:ea typeface="+mn-ea"/>
+        <a:cs typeface="+mn-cs"/>
+      </a:defRPr>
+    </a:lvl5pPr>
+    <a:lvl6pPr marL="2286000" algn="l" defTabSz="914400" rtl="0" eaLnBrk="1" latinLnBrk="0" hangingPunct="1">
+      <a:defRPr sz="1200" kern="1200">
+        <a:solidFill>
+          <a:schemeClr val="tx1"/>
+        </a:solidFill>
+        <a:latin typeface="+mn-lt"/>
+        <a:ea typeface="+mn-ea"/>
+        <a:cs typeface="+mn-cs"/>
+      </a:defRPr>
+    </a:lvl6pPr>
+    <a:lvl7pPr marL="2743200" algn="l" defTabSz="914400" rtl="0" eaLnBrk="1" latinLnBrk="0" hangingPunct="1">
+      <a:defRPr sz="1200" kern="1200">
+        <a:solidFill>
+          <a:schemeClr val="tx1"/>
+        </a:solidFill>
+        <a:latin typeface="+mn-lt"/>
+        <a:ea typeface="+mn-ea"/>
+        <a:cs typeface="+mn-cs"/>
+      </a:defRPr>
+    </a:lvl7pPr>
+    <a:lvl8pPr marL="3200400" algn="l" defTabSz="914400" rtl="0" eaLnBrk="1" latinLnBrk="0" hangingPunct="1">
+      <a:defRPr sz="1200" kern="1200">
+        <a:solidFill>
+          <a:schemeClr val="tx1"/>
+        </a:solidFill>
+        <a:latin typeface="+mn-lt"/>
+        <a:ea typeface="+mn-ea"/>
+        <a:cs typeface="+mn-cs"/>
+      </a:defRPr>
+    </a:lvl8pPr>
+    <a:lvl9pPr marL="3657600" algn="l" defTabSz="914400" rtl="0" eaLnBrk="1" latinLnBrk="0" hangingPunct="1">
+      <a:defRPr sz="1200" kern="1200">
+        <a:solidFill>
+          <a:schemeClr val="tx1"/>
+        </a:solidFill>
+        <a:latin typeface="+mn-lt"/>
+        <a:ea typeface="+mn-ea"/>
+        <a:cs typeface="+mn-cs"/>
+      </a:defRPr>
+    </a:lvl9pPr>
+  </p:notesStyle>
+</p:notesMaster>
+</file>
+
+<file path=ppt/notesSlides/notesSlide1.xml><?xml version="1.0" encoding="utf-8"?>
+<p:notes xmlns:a="http://schemas.openxmlformats.org/drawingml/2006/main" xmlns:r="http://schemas.openxmlformats.org/officeDocument/2006/relationships" xmlns:p="http://schemas.openxmlformats.org/presentationml/2006/main">
+  <p:cSld>
+    <p:spTree>
+      <p:nvGrpSpPr>
+        <p:cNvPr id="1" name=""/>
+        <p:cNvGrpSpPr/>
+        <p:nvPr/>
+      </p:nvGrpSpPr>
+      <p:grpSpPr>
+        <a:xfrm>
+          <a:off x="0" y="0"/>
+          <a:ext cx="0" cy="0"/>
+          <a:chOff x="0" y="0"/>
+          <a:chExt cx="0" cy="0"/>
+        </a:xfrm>
+      </p:grpSpPr>
+      <p:sp>
+        <p:nvSpPr>
+          <p:cNvPr id="2" name="슬라이드 이미지 개체 틀 1"/>
+          <p:cNvSpPr>
+            <a:spLocks noGrp="1" noRot="1" noChangeAspect="1"/>
+          </p:cNvSpPr>
+          <p:nvPr>
+            <p:ph type="sldImg"/>
+          </p:nvPr>
+        </p:nvSpPr>
+        <p:spPr/>
+      </p:sp>
+      <p:sp>
+        <p:nvSpPr>
+          <p:cNvPr id="3" name="슬라이드 노트 개체 틀 2"/>
+          <p:cNvSpPr>
+            <a:spLocks noGrp="1"/>
+          </p:cNvSpPr>
+          <p:nvPr>
+            <p:ph type="body" idx="1"/>
+          </p:nvPr>
+        </p:nvSpPr>
+        <p:spPr/>
+        <p:txBody>
+          <a:bodyPr/>
+          <a:lstStyle/>
+          <a:p>
+            <a:endParaRPr kumimoji="1" lang="ko-Kore-KR" altLang="en-US" dirty="0"/>
+          </a:p>
+        </p:txBody>
+      </p:sp>
+      <p:sp>
+        <p:nvSpPr>
+          <p:cNvPr id="4" name="슬라이드 번호 개체 틀 3"/>
+          <p:cNvSpPr>
+            <a:spLocks noGrp="1"/>
+          </p:cNvSpPr>
+          <p:nvPr>
+            <p:ph type="sldNum" sz="quarter" idx="5"/>
+          </p:nvPr>
+        </p:nvSpPr>
+        <p:spPr/>
+        <p:txBody>
+          <a:bodyPr/>
+          <a:lstStyle/>
+          <a:p>
+            <a:fld id="{7B3DB1E6-C265-D44D-9017-6CAC397A47BB}" type="slidenum">
+              <a:rPr kumimoji="1" lang="ko-Kore-KR" altLang="en-US" smtClean="0"/>
+              <a:t>5</a:t>
+            </a:fld>
+            <a:endParaRPr kumimoji="1" lang="ko-Kore-KR" altLang="en-US"/>
+          </a:p>
+        </p:txBody>
+      </p:sp>
+    </p:spTree>
+    <p:extLst>
+      <p:ext uri="{BB962C8B-B14F-4D97-AF65-F5344CB8AC3E}">
+        <p14:creationId xmlns:p14="http://schemas.microsoft.com/office/powerpoint/2010/main" val="1029717422"/>
+      </p:ext>
+    </p:extLst>
+  </p:cSld>
+  <p:clrMapOvr>
+    <a:masterClrMapping/>
+  </p:clrMapOvr>
+</p:notes>
 </file>
 
 <file path=ppt/slideLayouts/slideLayout1.xml><?xml version="1.0" encoding="utf-8"?>
@@ -163,10 +616,9 @@
           <a:lstStyle/>
           <a:p>
             <a:r>
-              <a:rPr lang="en-US" smtClean="0"/>
+              <a:rPr lang="en-US"/>
               <a:t>Click to edit Master title style</a:t>
             </a:r>
-            <a:endParaRPr lang="en-US"/>
           </a:p>
         </p:txBody>
       </p:sp>
@@ -282,10 +734,9 @@
           </a:lstStyle>
           <a:p>
             <a:r>
-              <a:rPr lang="en-US" smtClean="0"/>
+              <a:rPr lang="en-US"/>
               <a:t>Click to edit Master subtitle style</a:t>
             </a:r>
-            <a:endParaRPr lang="en-US"/>
           </a:p>
         </p:txBody>
       </p:sp>
@@ -306,7 +757,7 @@
           <a:p>
             <a:fld id="{5BCAD085-E8A6-8845-BD4E-CB4CCA059FC4}" type="datetimeFigureOut">
               <a:rPr lang="en-US" smtClean="0"/>
-              <a:t>1/27/13</a:t>
+              <a:t>6/27/26</a:t>
             </a:fld>
             <a:endParaRPr lang="en-US"/>
           </a:p>
@@ -400,10 +851,9 @@
           <a:lstStyle/>
           <a:p>
             <a:r>
-              <a:rPr lang="en-US" smtClean="0"/>
+              <a:rPr lang="en-US"/>
               <a:t>Click to edit Master title style</a:t>
             </a:r>
-            <a:endParaRPr lang="en-US"/>
           </a:p>
         </p:txBody>
       </p:sp>
@@ -424,38 +874,37 @@
           <a:p>
             <a:pPr lvl="0"/>
             <a:r>
-              <a:rPr lang="en-US" smtClean="0"/>
+              <a:rPr lang="en-US"/>
               <a:t>Click to edit Master text styles</a:t>
             </a:r>
           </a:p>
           <a:p>
             <a:pPr lvl="1"/>
             <a:r>
-              <a:rPr lang="en-US" smtClean="0"/>
+              <a:rPr lang="en-US"/>
               <a:t>Second level</a:t>
             </a:r>
           </a:p>
           <a:p>
             <a:pPr lvl="2"/>
             <a:r>
-              <a:rPr lang="en-US" smtClean="0"/>
+              <a:rPr lang="en-US"/>
               <a:t>Third level</a:t>
             </a:r>
           </a:p>
           <a:p>
             <a:pPr lvl="3"/>
             <a:r>
-              <a:rPr lang="en-US" smtClean="0"/>
+              <a:rPr lang="en-US"/>
               <a:t>Fourth level</a:t>
             </a:r>
           </a:p>
           <a:p>
             <a:pPr lvl="4"/>
             <a:r>
-              <a:rPr lang="en-US" smtClean="0"/>
+              <a:rPr lang="en-US"/>
               <a:t>Fifth level</a:t>
             </a:r>
-            <a:endParaRPr lang="en-US"/>
           </a:p>
         </p:txBody>
       </p:sp>
@@ -476,7 +925,7 @@
           <a:p>
             <a:fld id="{5BCAD085-E8A6-8845-BD4E-CB4CCA059FC4}" type="datetimeFigureOut">
               <a:rPr lang="en-US" smtClean="0"/>
-              <a:t>1/27/13</a:t>
+              <a:t>6/27/26</a:t>
             </a:fld>
             <a:endParaRPr lang="en-US"/>
           </a:p>
@@ -575,10 +1024,9 @@
           <a:lstStyle/>
           <a:p>
             <a:r>
-              <a:rPr lang="en-US" smtClean="0"/>
+              <a:rPr lang="en-US"/>
               <a:t>Click to edit Master title style</a:t>
             </a:r>
-            <a:endParaRPr lang="en-US"/>
           </a:p>
         </p:txBody>
       </p:sp>
@@ -604,38 +1052,37 @@
           <a:p>
             <a:pPr lvl="0"/>
             <a:r>
-              <a:rPr lang="en-US" smtClean="0"/>
+              <a:rPr lang="en-US"/>
               <a:t>Click to edit Master text styles</a:t>
             </a:r>
           </a:p>
           <a:p>
             <a:pPr lvl="1"/>
             <a:r>
-              <a:rPr lang="en-US" smtClean="0"/>
+              <a:rPr lang="en-US"/>
               <a:t>Second level</a:t>
             </a:r>
           </a:p>
           <a:p>
             <a:pPr lvl="2"/>
             <a:r>
-              <a:rPr lang="en-US" smtClean="0"/>
+              <a:rPr lang="en-US"/>
               <a:t>Third level</a:t>
             </a:r>
           </a:p>
           <a:p>
             <a:pPr lvl="3"/>
             <a:r>
-              <a:rPr lang="en-US" smtClean="0"/>
+              <a:rPr lang="en-US"/>
               <a:t>Fourth level</a:t>
             </a:r>
           </a:p>
           <a:p>
             <a:pPr lvl="4"/>
             <a:r>
-              <a:rPr lang="en-US" smtClean="0"/>
+              <a:rPr lang="en-US"/>
               <a:t>Fifth level</a:t>
             </a:r>
-            <a:endParaRPr lang="en-US"/>
           </a:p>
         </p:txBody>
       </p:sp>
@@ -656,7 +1103,7 @@
           <a:p>
             <a:fld id="{5BCAD085-E8A6-8845-BD4E-CB4CCA059FC4}" type="datetimeFigureOut">
               <a:rPr lang="en-US" smtClean="0"/>
-              <a:t>1/27/13</a:t>
+              <a:t>6/27/26</a:t>
             </a:fld>
             <a:endParaRPr lang="en-US"/>
           </a:p>
@@ -750,10 +1197,9 @@
           <a:lstStyle/>
           <a:p>
             <a:r>
-              <a:rPr lang="en-US" smtClean="0"/>
+              <a:rPr lang="en-US"/>
               <a:t>Click to edit Master title style</a:t>
             </a:r>
-            <a:endParaRPr lang="en-US"/>
           </a:p>
         </p:txBody>
       </p:sp>
@@ -774,38 +1220,37 @@
           <a:p>
             <a:pPr lvl="0"/>
             <a:r>
-              <a:rPr lang="en-US" smtClean="0"/>
+              <a:rPr lang="en-US"/>
               <a:t>Click to edit Master text styles</a:t>
             </a:r>
           </a:p>
           <a:p>
             <a:pPr lvl="1"/>
             <a:r>
-              <a:rPr lang="en-US" smtClean="0"/>
+              <a:rPr lang="en-US"/>
               <a:t>Second level</a:t>
             </a:r>
           </a:p>
           <a:p>
             <a:pPr lvl="2"/>
             <a:r>
-              <a:rPr lang="en-US" smtClean="0"/>
+              <a:rPr lang="en-US"/>
               <a:t>Third level</a:t>
             </a:r>
           </a:p>
           <a:p>
             <a:pPr lvl="3"/>
             <a:r>
-              <a:rPr lang="en-US" smtClean="0"/>
+              <a:rPr lang="en-US"/>
               <a:t>Fourth level</a:t>
             </a:r>
           </a:p>
           <a:p>
             <a:pPr lvl="4"/>
             <a:r>
-              <a:rPr lang="en-US" smtClean="0"/>
+              <a:rPr lang="en-US"/>
               <a:t>Fifth level</a:t>
             </a:r>
-            <a:endParaRPr lang="en-US"/>
           </a:p>
         </p:txBody>
       </p:sp>
@@ -826,7 +1271,7 @@
           <a:p>
             <a:fld id="{5BCAD085-E8A6-8845-BD4E-CB4CCA059FC4}" type="datetimeFigureOut">
               <a:rPr lang="en-US" smtClean="0"/>
-              <a:t>1/27/13</a:t>
+              <a:t>6/27/26</a:t>
             </a:fld>
             <a:endParaRPr lang="en-US"/>
           </a:p>
@@ -929,10 +1374,9 @@
           </a:lstStyle>
           <a:p>
             <a:r>
-              <a:rPr lang="en-US" smtClean="0"/>
+              <a:rPr lang="en-US"/>
               <a:t>Click to edit Master title style</a:t>
             </a:r>
-            <a:endParaRPr lang="en-US"/>
           </a:p>
         </p:txBody>
       </p:sp>
@@ -1049,7 +1493,7 @@
           <a:p>
             <a:pPr lvl="0"/>
             <a:r>
-              <a:rPr lang="en-US" smtClean="0"/>
+              <a:rPr lang="en-US"/>
               <a:t>Click to edit Master text styles</a:t>
             </a:r>
           </a:p>
@@ -1072,7 +1516,7 @@
           <a:p>
             <a:fld id="{5BCAD085-E8A6-8845-BD4E-CB4CCA059FC4}" type="datetimeFigureOut">
               <a:rPr lang="en-US" smtClean="0"/>
-              <a:t>1/27/13</a:t>
+              <a:t>6/27/26</a:t>
             </a:fld>
             <a:endParaRPr lang="en-US"/>
           </a:p>
@@ -1166,10 +1610,9 @@
           <a:lstStyle/>
           <a:p>
             <a:r>
-              <a:rPr lang="en-US" smtClean="0"/>
+              <a:rPr lang="en-US"/>
               <a:t>Click to edit Master title style</a:t>
             </a:r>
-            <a:endParaRPr lang="en-US"/>
           </a:p>
         </p:txBody>
       </p:sp>
@@ -1223,38 +1666,37 @@
           <a:p>
             <a:pPr lvl="0"/>
             <a:r>
-              <a:rPr lang="en-US" smtClean="0"/>
+              <a:rPr lang="en-US"/>
               <a:t>Click to edit Master text styles</a:t>
             </a:r>
           </a:p>
           <a:p>
             <a:pPr lvl="1"/>
             <a:r>
-              <a:rPr lang="en-US" smtClean="0"/>
+              <a:rPr lang="en-US"/>
               <a:t>Second level</a:t>
             </a:r>
           </a:p>
           <a:p>
             <a:pPr lvl="2"/>
             <a:r>
-              <a:rPr lang="en-US" smtClean="0"/>
+              <a:rPr lang="en-US"/>
               <a:t>Third level</a:t>
             </a:r>
           </a:p>
           <a:p>
             <a:pPr lvl="3"/>
             <a:r>
-              <a:rPr lang="en-US" smtClean="0"/>
+              <a:rPr lang="en-US"/>
               <a:t>Fourth level</a:t>
             </a:r>
           </a:p>
           <a:p>
             <a:pPr lvl="4"/>
             <a:r>
-              <a:rPr lang="en-US" smtClean="0"/>
+              <a:rPr lang="en-US"/>
               <a:t>Fifth level</a:t>
             </a:r>
-            <a:endParaRPr lang="en-US"/>
           </a:p>
         </p:txBody>
       </p:sp>
@@ -1308,38 +1750,37 @@
           <a:p>
             <a:pPr lvl="0"/>
             <a:r>
-              <a:rPr lang="en-US" smtClean="0"/>
+              <a:rPr lang="en-US"/>
               <a:t>Click to edit Master text styles</a:t>
             </a:r>
           </a:p>
           <a:p>
             <a:pPr lvl="1"/>
             <a:r>
-              <a:rPr lang="en-US" smtClean="0"/>
+              <a:rPr lang="en-US"/>
               <a:t>Second level</a:t>
             </a:r>
           </a:p>
           <a:p>
             <a:pPr lvl="2"/>
             <a:r>
-              <a:rPr lang="en-US" smtClean="0"/>
+              <a:rPr lang="en-US"/>
               <a:t>Third level</a:t>
             </a:r>
           </a:p>
           <a:p>
             <a:pPr lvl="3"/>
             <a:r>
-              <a:rPr lang="en-US" smtClean="0"/>
+              <a:rPr lang="en-US"/>
               <a:t>Fourth level</a:t>
             </a:r>
           </a:p>
           <a:p>
             <a:pPr lvl="4"/>
             <a:r>
-              <a:rPr lang="en-US" smtClean="0"/>
+              <a:rPr lang="en-US"/>
               <a:t>Fifth level</a:t>
             </a:r>
-            <a:endParaRPr lang="en-US"/>
           </a:p>
         </p:txBody>
       </p:sp>
@@ -1360,7 +1801,7 @@
           <a:p>
             <a:fld id="{5BCAD085-E8A6-8845-BD4E-CB4CCA059FC4}" type="datetimeFigureOut">
               <a:rPr lang="en-US" smtClean="0"/>
-              <a:t>1/27/13</a:t>
+              <a:t>6/27/26</a:t>
             </a:fld>
             <a:endParaRPr lang="en-US"/>
           </a:p>
@@ -1458,10 +1899,9 @@
           </a:lstStyle>
           <a:p>
             <a:r>
-              <a:rPr lang="en-US" smtClean="0"/>
+              <a:rPr lang="en-US"/>
               <a:t>Click to edit Master title style</a:t>
             </a:r>
-            <a:endParaRPr lang="en-US"/>
           </a:p>
         </p:txBody>
       </p:sp>
@@ -1524,7 +1964,7 @@
           <a:p>
             <a:pPr lvl="0"/>
             <a:r>
-              <a:rPr lang="en-US" smtClean="0"/>
+              <a:rPr lang="en-US"/>
               <a:t>Click to edit Master text styles</a:t>
             </a:r>
           </a:p>
@@ -1580,38 +2020,37 @@
           <a:p>
             <a:pPr lvl="0"/>
             <a:r>
-              <a:rPr lang="en-US" smtClean="0"/>
+              <a:rPr lang="en-US"/>
               <a:t>Click to edit Master text styles</a:t>
             </a:r>
           </a:p>
           <a:p>
             <a:pPr lvl="1"/>
             <a:r>
-              <a:rPr lang="en-US" smtClean="0"/>
+              <a:rPr lang="en-US"/>
               <a:t>Second level</a:t>
             </a:r>
           </a:p>
           <a:p>
             <a:pPr lvl="2"/>
             <a:r>
-              <a:rPr lang="en-US" smtClean="0"/>
+              <a:rPr lang="en-US"/>
               <a:t>Third level</a:t>
             </a:r>
           </a:p>
           <a:p>
             <a:pPr lvl="3"/>
             <a:r>
-              <a:rPr lang="en-US" smtClean="0"/>
+              <a:rPr lang="en-US"/>
               <a:t>Fourth level</a:t>
             </a:r>
           </a:p>
           <a:p>
             <a:pPr lvl="4"/>
             <a:r>
-              <a:rPr lang="en-US" smtClean="0"/>
+              <a:rPr lang="en-US"/>
               <a:t>Fifth level</a:t>
             </a:r>
-            <a:endParaRPr lang="en-US"/>
           </a:p>
         </p:txBody>
       </p:sp>
@@ -1674,7 +2113,7 @@
           <a:p>
             <a:pPr lvl="0"/>
             <a:r>
-              <a:rPr lang="en-US" smtClean="0"/>
+              <a:rPr lang="en-US"/>
               <a:t>Click to edit Master text styles</a:t>
             </a:r>
           </a:p>
@@ -1730,38 +2169,37 @@
           <a:p>
             <a:pPr lvl="0"/>
             <a:r>
-              <a:rPr lang="en-US" smtClean="0"/>
+              <a:rPr lang="en-US"/>
               <a:t>Click to edit Master text styles</a:t>
             </a:r>
           </a:p>
           <a:p>
             <a:pPr lvl="1"/>
             <a:r>
-              <a:rPr lang="en-US" smtClean="0"/>
+              <a:rPr lang="en-US"/>
               <a:t>Second level</a:t>
             </a:r>
           </a:p>
           <a:p>
             <a:pPr lvl="2"/>
             <a:r>
-              <a:rPr lang="en-US" smtClean="0"/>
+              <a:rPr lang="en-US"/>
               <a:t>Third level</a:t>
             </a:r>
           </a:p>
           <a:p>
             <a:pPr lvl="3"/>
             <a:r>
-              <a:rPr lang="en-US" smtClean="0"/>
+              <a:rPr lang="en-US"/>
               <a:t>Fourth level</a:t>
             </a:r>
           </a:p>
           <a:p>
             <a:pPr lvl="4"/>
             <a:r>
-              <a:rPr lang="en-US" smtClean="0"/>
+              <a:rPr lang="en-US"/>
               <a:t>Fifth level</a:t>
             </a:r>
-            <a:endParaRPr lang="en-US"/>
           </a:p>
         </p:txBody>
       </p:sp>
@@ -1782,7 +2220,7 @@
           <a:p>
             <a:fld id="{5BCAD085-E8A6-8845-BD4E-CB4CCA059FC4}" type="datetimeFigureOut">
               <a:rPr lang="en-US" smtClean="0"/>
-              <a:t>1/27/13</a:t>
+              <a:t>6/27/26</a:t>
             </a:fld>
             <a:endParaRPr lang="en-US"/>
           </a:p>
@@ -1876,10 +2314,9 @@
           <a:lstStyle/>
           <a:p>
             <a:r>
-              <a:rPr lang="en-US" smtClean="0"/>
+              <a:rPr lang="en-US"/>
               <a:t>Click to edit Master title style</a:t>
             </a:r>
-            <a:endParaRPr lang="en-US"/>
           </a:p>
         </p:txBody>
       </p:sp>
@@ -1900,7 +2337,7 @@
           <a:p>
             <a:fld id="{5BCAD085-E8A6-8845-BD4E-CB4CCA059FC4}" type="datetimeFigureOut">
               <a:rPr lang="en-US" smtClean="0"/>
-              <a:t>1/27/13</a:t>
+              <a:t>6/27/26</a:t>
             </a:fld>
             <a:endParaRPr lang="en-US"/>
           </a:p>
@@ -1995,7 +2432,7 @@
           <a:p>
             <a:fld id="{5BCAD085-E8A6-8845-BD4E-CB4CCA059FC4}" type="datetimeFigureOut">
               <a:rPr lang="en-US" smtClean="0"/>
-              <a:t>1/27/13</a:t>
+              <a:t>6/27/26</a:t>
             </a:fld>
             <a:endParaRPr lang="en-US"/>
           </a:p>
@@ -2098,10 +2535,9 @@
           </a:lstStyle>
           <a:p>
             <a:r>
-              <a:rPr lang="en-US" smtClean="0"/>
+              <a:rPr lang="en-US"/>
               <a:t>Click to edit Master title style</a:t>
             </a:r>
-            <a:endParaRPr lang="en-US"/>
           </a:p>
         </p:txBody>
       </p:sp>
@@ -2155,38 +2591,37 @@
           <a:p>
             <a:pPr lvl="0"/>
             <a:r>
-              <a:rPr lang="en-US" smtClean="0"/>
+              <a:rPr lang="en-US"/>
               <a:t>Click to edit Master text styles</a:t>
             </a:r>
           </a:p>
           <a:p>
             <a:pPr lvl="1"/>
             <a:r>
-              <a:rPr lang="en-US" smtClean="0"/>
+              <a:rPr lang="en-US"/>
               <a:t>Second level</a:t>
             </a:r>
           </a:p>
           <a:p>
             <a:pPr lvl="2"/>
             <a:r>
-              <a:rPr lang="en-US" smtClean="0"/>
+              <a:rPr lang="en-US"/>
               <a:t>Third level</a:t>
             </a:r>
           </a:p>
           <a:p>
             <a:pPr lvl="3"/>
             <a:r>
-              <a:rPr lang="en-US" smtClean="0"/>
+              <a:rPr lang="en-US"/>
               <a:t>Fourth level</a:t>
             </a:r>
           </a:p>
           <a:p>
             <a:pPr lvl="4"/>
             <a:r>
-              <a:rPr lang="en-US" smtClean="0"/>
+              <a:rPr lang="en-US"/>
               <a:t>Fifth level</a:t>
             </a:r>
-            <a:endParaRPr lang="en-US"/>
           </a:p>
         </p:txBody>
       </p:sp>
@@ -2249,7 +2684,7 @@
           <a:p>
             <a:pPr lvl="0"/>
             <a:r>
-              <a:rPr lang="en-US" smtClean="0"/>
+              <a:rPr lang="en-US"/>
               <a:t>Click to edit Master text styles</a:t>
             </a:r>
           </a:p>
@@ -2272,7 +2707,7 @@
           <a:p>
             <a:fld id="{5BCAD085-E8A6-8845-BD4E-CB4CCA059FC4}" type="datetimeFigureOut">
               <a:rPr lang="en-US" smtClean="0"/>
-              <a:t>1/27/13</a:t>
+              <a:t>6/27/26</a:t>
             </a:fld>
             <a:endParaRPr lang="en-US"/>
           </a:p>
@@ -2375,10 +2810,9 @@
           </a:lstStyle>
           <a:p>
             <a:r>
-              <a:rPr lang="en-US" smtClean="0"/>
+              <a:rPr lang="en-US"/>
               <a:t>Click to edit Master title style</a:t>
             </a:r>
-            <a:endParaRPr lang="en-US"/>
           </a:p>
         </p:txBody>
       </p:sp>
@@ -2502,7 +2936,7 @@
           <a:p>
             <a:pPr lvl="0"/>
             <a:r>
-              <a:rPr lang="en-US" smtClean="0"/>
+              <a:rPr lang="en-US"/>
               <a:t>Click to edit Master text styles</a:t>
             </a:r>
           </a:p>
@@ -2525,7 +2959,7 @@
           <a:p>
             <a:fld id="{5BCAD085-E8A6-8845-BD4E-CB4CCA059FC4}" type="datetimeFigureOut">
               <a:rPr lang="en-US" smtClean="0"/>
-              <a:t>1/27/13</a:t>
+              <a:t>6/27/26</a:t>
             </a:fld>
             <a:endParaRPr lang="en-US"/>
           </a:p>
@@ -2634,10 +3068,9 @@
           <a:lstStyle/>
           <a:p>
             <a:r>
-              <a:rPr lang="en-US" smtClean="0"/>
+              <a:rPr lang="en-US"/>
               <a:t>Click to edit Master title style</a:t>
             </a:r>
-            <a:endParaRPr lang="en-US"/>
           </a:p>
         </p:txBody>
       </p:sp>
@@ -2668,38 +3101,37 @@
           <a:p>
             <a:pPr lvl="0"/>
             <a:r>
-              <a:rPr lang="en-US" smtClean="0"/>
+              <a:rPr lang="en-US"/>
               <a:t>Click to edit Master text styles</a:t>
             </a:r>
           </a:p>
           <a:p>
             <a:pPr lvl="1"/>
             <a:r>
-              <a:rPr lang="en-US" smtClean="0"/>
+              <a:rPr lang="en-US"/>
               <a:t>Second level</a:t>
             </a:r>
           </a:p>
           <a:p>
             <a:pPr lvl="2"/>
             <a:r>
-              <a:rPr lang="en-US" smtClean="0"/>
+              <a:rPr lang="en-US"/>
               <a:t>Third level</a:t>
             </a:r>
           </a:p>
           <a:p>
             <a:pPr lvl="3"/>
             <a:r>
-              <a:rPr lang="en-US" smtClean="0"/>
+              <a:rPr lang="en-US"/>
               <a:t>Fourth level</a:t>
             </a:r>
           </a:p>
           <a:p>
             <a:pPr lvl="4"/>
             <a:r>
-              <a:rPr lang="en-US" smtClean="0"/>
+              <a:rPr lang="en-US"/>
               <a:t>Fifth level</a:t>
             </a:r>
-            <a:endParaRPr lang="en-US"/>
           </a:p>
         </p:txBody>
       </p:sp>
@@ -2738,7 +3170,7 @@
           <a:p>
             <a:fld id="{5BCAD085-E8A6-8845-BD4E-CB4CCA059FC4}" type="datetimeFigureOut">
               <a:rPr lang="en-US" smtClean="0"/>
-              <a:t>1/27/13</a:t>
+              <a:t>6/27/26</a:t>
             </a:fld>
             <a:endParaRPr lang="en-US"/>
           </a:p>
@@ -3097,7 +3529,7 @@
 </file>
 
 <file path=ppt/slides/slide1.xml><?xml version="1.0" encoding="utf-8"?>
-<p:sld xmlns:a="http://schemas.openxmlformats.org/drawingml/2006/main" xmlns:p="http://schemas.openxmlformats.org/presentationml/2006/main" xmlns:r="http://schemas.openxmlformats.org/officeDocument/2006/relationships">
+<p:sld xmlns:a="http://schemas.openxmlformats.org/drawingml/2006/main" xmlns:r="http://schemas.openxmlformats.org/officeDocument/2006/relationships" xmlns:p="http://schemas.openxmlformats.org/presentationml/2006/main">
   <p:cSld>
     <p:spTree>
       <p:nvGrpSpPr>
@@ -3105,7 +3537,14 @@
         <p:cNvGrpSpPr/>
         <p:nvPr/>
       </p:nvGrpSpPr>
-      <p:grpSpPr/>
+      <p:grpSpPr>
+        <a:xfrm>
+          <a:off x="0" y="0"/>
+          <a:ext cx="0" cy="0"/>
+          <a:chOff x="0" y="0"/>
+          <a:chExt cx="0" cy="0"/>
+        </a:xfrm>
+      </p:grpSpPr>
       <p:sp>
         <p:nvSpPr>
           <p:cNvPr id="2" name="Rectangle 1"/>
@@ -3147,6 +3586,7 @@
           <a:lstStyle/>
           <a:p>
             <a:pPr algn="ctr"/>
+            <a:endParaRPr/>
           </a:p>
         </p:txBody>
       </p:sp>
@@ -3191,6 +3631,7 @@
           <a:lstStyle/>
           <a:p>
             <a:pPr algn="ctr"/>
+            <a:endParaRPr/>
           </a:p>
         </p:txBody>
       </p:sp>
@@ -3211,7 +3652,7 @@
           <a:noFill/>
         </p:spPr>
         <p:txBody>
-          <a:bodyPr wrap="square" anchor="t" lIns="45720" rIns="45720" tIns="27432" bIns="27432">
+          <a:bodyPr wrap="square" lIns="45720" tIns="27432" rIns="45720" bIns="27432" anchor="t">
             <a:spAutoFit/>
           </a:bodyPr>
           <a:lstStyle/>
@@ -3252,7 +3693,7 @@
           <a:noFill/>
         </p:spPr>
         <p:txBody>
-          <a:bodyPr wrap="square" anchor="t" lIns="45720" rIns="45720" tIns="27432" bIns="27432">
+          <a:bodyPr wrap="square" lIns="45720" tIns="27432" rIns="45720" bIns="27432" anchor="t">
             <a:spAutoFit/>
           </a:bodyPr>
           <a:lstStyle/>
@@ -3285,7 +3726,7 @@
 </file>
 
 <file path=ppt/slides/slide10.xml><?xml version="1.0" encoding="utf-8"?>
-<p:sld xmlns:a="http://schemas.openxmlformats.org/drawingml/2006/main" xmlns:p="http://schemas.openxmlformats.org/presentationml/2006/main" xmlns:r="http://schemas.openxmlformats.org/officeDocument/2006/relationships">
+<p:sld xmlns:a="http://schemas.openxmlformats.org/drawingml/2006/main" xmlns:r="http://schemas.openxmlformats.org/officeDocument/2006/relationships" xmlns:p="http://schemas.openxmlformats.org/presentationml/2006/main">
   <p:cSld>
     <p:spTree>
       <p:nvGrpSpPr>
@@ -3293,7 +3734,14 @@
         <p:cNvGrpSpPr/>
         <p:nvPr/>
       </p:nvGrpSpPr>
-      <p:grpSpPr/>
+      <p:grpSpPr>
+        <a:xfrm>
+          <a:off x="0" y="0"/>
+          <a:ext cx="0" cy="0"/>
+          <a:chOff x="0" y="0"/>
+          <a:chExt cx="0" cy="0"/>
+        </a:xfrm>
+      </p:grpSpPr>
       <p:sp>
         <p:nvSpPr>
           <p:cNvPr id="2" name="Rectangle 1"/>
@@ -3335,6 +3783,7 @@
           <a:lstStyle/>
           <a:p>
             <a:pPr algn="ctr"/>
+            <a:endParaRPr/>
           </a:p>
         </p:txBody>
       </p:sp>
@@ -3379,6 +3828,7 @@
           <a:lstStyle/>
           <a:p>
             <a:pPr algn="ctr"/>
+            <a:endParaRPr/>
           </a:p>
         </p:txBody>
       </p:sp>
@@ -3399,7 +3849,7 @@
           <a:noFill/>
         </p:spPr>
         <p:txBody>
-          <a:bodyPr wrap="square" anchor="t" lIns="45720" rIns="45720" tIns="27432" bIns="27432">
+          <a:bodyPr wrap="square" lIns="45720" tIns="27432" rIns="45720" bIns="27432" anchor="t">
             <a:spAutoFit/>
           </a:bodyPr>
           <a:lstStyle/>
@@ -3440,7 +3890,7 @@
           <a:noFill/>
         </p:spPr>
         <p:txBody>
-          <a:bodyPr wrap="square" anchor="t" lIns="45720" rIns="45720" tIns="27432" bIns="27432">
+          <a:bodyPr wrap="square" lIns="45720" tIns="27432" rIns="45720" bIns="27432" anchor="t">
             <a:spAutoFit/>
           </a:bodyPr>
           <a:lstStyle/>
@@ -3579,6 +4029,7 @@
           <a:lstStyle/>
           <a:p>
             <a:pPr algn="ctr"/>
+            <a:endParaRPr/>
           </a:p>
         </p:txBody>
       </p:sp>
@@ -3599,7 +4050,7 @@
           <a:noFill/>
         </p:spPr>
         <p:txBody>
-          <a:bodyPr wrap="square" anchor="ctr" lIns="45720" rIns="45720" tIns="27432" bIns="27432">
+          <a:bodyPr wrap="square" lIns="45720" tIns="27432" rIns="45720" bIns="27432" anchor="ctr">
             <a:spAutoFit/>
           </a:bodyPr>
           <a:lstStyle/>
@@ -3640,7 +4091,7 @@
           <a:noFill/>
         </p:spPr>
         <p:txBody>
-          <a:bodyPr wrap="square" anchor="ctr" lIns="45720" rIns="45720" tIns="27432" bIns="27432">
+          <a:bodyPr wrap="square" lIns="45720" tIns="27432" rIns="45720" bIns="27432" anchor="ctr">
             <a:spAutoFit/>
           </a:bodyPr>
           <a:lstStyle/>
@@ -3673,7 +4124,7 @@
 </file>
 
 <file path=ppt/slides/slide11.xml><?xml version="1.0" encoding="utf-8"?>
-<p:sld xmlns:a="http://schemas.openxmlformats.org/drawingml/2006/main" xmlns:p="http://schemas.openxmlformats.org/presentationml/2006/main" xmlns:r="http://schemas.openxmlformats.org/officeDocument/2006/relationships">
+<p:sld xmlns:a="http://schemas.openxmlformats.org/drawingml/2006/main" xmlns:r="http://schemas.openxmlformats.org/officeDocument/2006/relationships" xmlns:p="http://schemas.openxmlformats.org/presentationml/2006/main">
   <p:cSld>
     <p:spTree>
       <p:nvGrpSpPr>
@@ -3681,7 +4132,14 @@
         <p:cNvGrpSpPr/>
         <p:nvPr/>
       </p:nvGrpSpPr>
-      <p:grpSpPr/>
+      <p:grpSpPr>
+        <a:xfrm>
+          <a:off x="0" y="0"/>
+          <a:ext cx="0" cy="0"/>
+          <a:chOff x="0" y="0"/>
+          <a:chExt cx="0" cy="0"/>
+        </a:xfrm>
+      </p:grpSpPr>
       <p:sp>
         <p:nvSpPr>
           <p:cNvPr id="2" name="Rectangle 1"/>
@@ -3723,6 +4181,7 @@
           <a:lstStyle/>
           <a:p>
             <a:pPr algn="ctr"/>
+            <a:endParaRPr/>
           </a:p>
         </p:txBody>
       </p:sp>
@@ -3767,6 +4226,7 @@
           <a:lstStyle/>
           <a:p>
             <a:pPr algn="ctr"/>
+            <a:endParaRPr/>
           </a:p>
         </p:txBody>
       </p:sp>
@@ -3787,7 +4247,7 @@
           <a:noFill/>
         </p:spPr>
         <p:txBody>
-          <a:bodyPr wrap="square" anchor="t" lIns="45720" rIns="45720" tIns="27432" bIns="27432">
+          <a:bodyPr wrap="square" lIns="45720" tIns="27432" rIns="45720" bIns="27432" anchor="t">
             <a:spAutoFit/>
           </a:bodyPr>
           <a:lstStyle/>
@@ -3828,7 +4288,7 @@
           <a:noFill/>
         </p:spPr>
         <p:txBody>
-          <a:bodyPr wrap="square" anchor="t" lIns="45720" rIns="45720" tIns="27432" bIns="27432">
+          <a:bodyPr wrap="square" lIns="45720" tIns="27432" rIns="45720" bIns="27432" anchor="t">
             <a:spAutoFit/>
           </a:bodyPr>
           <a:lstStyle/>
@@ -3931,6 +4391,7 @@
           <a:lstStyle/>
           <a:p>
             <a:pPr algn="ctr"/>
+            <a:endParaRPr/>
           </a:p>
         </p:txBody>
       </p:sp>
@@ -3951,7 +4412,7 @@
           <a:noFill/>
         </p:spPr>
         <p:txBody>
-          <a:bodyPr wrap="square" anchor="ctr" lIns="45720" rIns="45720" tIns="27432" bIns="27432">
+          <a:bodyPr wrap="square" lIns="45720" tIns="27432" rIns="45720" bIns="27432" anchor="ctr">
             <a:spAutoFit/>
           </a:bodyPr>
           <a:lstStyle/>
@@ -3992,7 +4453,7 @@
           <a:noFill/>
         </p:spPr>
         <p:txBody>
-          <a:bodyPr wrap="square" anchor="ctr" lIns="45720" rIns="45720" tIns="27432" bIns="27432">
+          <a:bodyPr wrap="square" lIns="45720" tIns="27432" rIns="45720" bIns="27432" anchor="ctr">
             <a:spAutoFit/>
           </a:bodyPr>
           <a:lstStyle/>
@@ -4025,7 +4486,7 @@
 </file>
 
 <file path=ppt/slides/slide12.xml><?xml version="1.0" encoding="utf-8"?>
-<p:sld xmlns:a="http://schemas.openxmlformats.org/drawingml/2006/main" xmlns:p="http://schemas.openxmlformats.org/presentationml/2006/main" xmlns:r="http://schemas.openxmlformats.org/officeDocument/2006/relationships">
+<p:sld xmlns:a="http://schemas.openxmlformats.org/drawingml/2006/main" xmlns:r="http://schemas.openxmlformats.org/officeDocument/2006/relationships" xmlns:p="http://schemas.openxmlformats.org/presentationml/2006/main">
   <p:cSld>
     <p:spTree>
       <p:nvGrpSpPr>
@@ -4033,7 +4494,14 @@
         <p:cNvGrpSpPr/>
         <p:nvPr/>
       </p:nvGrpSpPr>
-      <p:grpSpPr/>
+      <p:grpSpPr>
+        <a:xfrm>
+          <a:off x="0" y="0"/>
+          <a:ext cx="0" cy="0"/>
+          <a:chOff x="0" y="0"/>
+          <a:chExt cx="0" cy="0"/>
+        </a:xfrm>
+      </p:grpSpPr>
       <p:sp>
         <p:nvSpPr>
           <p:cNvPr id="2" name="Rectangle 1"/>
@@ -4075,6 +4543,7 @@
           <a:lstStyle/>
           <a:p>
             <a:pPr algn="ctr"/>
+            <a:endParaRPr/>
           </a:p>
         </p:txBody>
       </p:sp>
@@ -4119,6 +4588,7 @@
           <a:lstStyle/>
           <a:p>
             <a:pPr algn="ctr"/>
+            <a:endParaRPr/>
           </a:p>
         </p:txBody>
       </p:sp>
@@ -4139,7 +4609,7 @@
           <a:noFill/>
         </p:spPr>
         <p:txBody>
-          <a:bodyPr wrap="square" anchor="t" lIns="45720" rIns="45720" tIns="27432" bIns="27432">
+          <a:bodyPr wrap="square" lIns="45720" tIns="27432" rIns="45720" bIns="27432" anchor="t">
             <a:spAutoFit/>
           </a:bodyPr>
           <a:lstStyle/>
@@ -4180,7 +4650,7 @@
           <a:noFill/>
         </p:spPr>
         <p:txBody>
-          <a:bodyPr wrap="square" anchor="t" lIns="45720" rIns="45720" tIns="27432" bIns="27432">
+          <a:bodyPr wrap="square" lIns="45720" tIns="27432" rIns="45720" bIns="27432" anchor="t">
             <a:spAutoFit/>
           </a:bodyPr>
           <a:lstStyle/>
@@ -4283,6 +4753,7 @@
           <a:lstStyle/>
           <a:p>
             <a:pPr algn="ctr"/>
+            <a:endParaRPr/>
           </a:p>
         </p:txBody>
       </p:sp>
@@ -4303,7 +4774,7 @@
           <a:noFill/>
         </p:spPr>
         <p:txBody>
-          <a:bodyPr wrap="square" anchor="ctr" lIns="45720" rIns="45720" tIns="27432" bIns="27432">
+          <a:bodyPr wrap="square" lIns="45720" tIns="27432" rIns="45720" bIns="27432" anchor="ctr">
             <a:spAutoFit/>
           </a:bodyPr>
           <a:lstStyle/>
@@ -4344,7 +4815,7 @@
           <a:noFill/>
         </p:spPr>
         <p:txBody>
-          <a:bodyPr wrap="square" anchor="ctr" lIns="45720" rIns="45720" tIns="27432" bIns="27432">
+          <a:bodyPr wrap="square" lIns="45720" tIns="27432" rIns="45720" bIns="27432" anchor="ctr">
             <a:spAutoFit/>
           </a:bodyPr>
           <a:lstStyle/>
@@ -4368,6 +4839,36 @@
           </a:p>
         </p:txBody>
       </p:sp>
+      <p:pic>
+        <p:nvPicPr>
+          <p:cNvPr id="9" name="그림 8" descr="텍스트, 스크린샷, 폰트, 번호이(가) 표시된 사진&#10;&#10;AI 생성 콘텐츠는 정확하지 않을 수 있습니다.">
+            <a:extLst>
+              <a:ext uri="{FF2B5EF4-FFF2-40B4-BE49-F238E27FC236}">
+                <a16:creationId xmlns:a16="http://schemas.microsoft.com/office/drawing/2014/main" id="{C2D4288B-F461-5756-C0BE-6EAC397A03F7}"/>
+              </a:ext>
+            </a:extLst>
+          </p:cNvPr>
+          <p:cNvPicPr>
+            <a:picLocks noChangeAspect="1"/>
+          </p:cNvPicPr>
+          <p:nvPr/>
+        </p:nvPicPr>
+        <p:blipFill>
+          <a:blip r:embed="rId2"/>
+          <a:stretch>
+            <a:fillRect/>
+          </a:stretch>
+        </p:blipFill>
+        <p:spPr>
+          <a:xfrm>
+            <a:off x="7955279" y="0"/>
+            <a:ext cx="3642361" cy="6858000"/>
+          </a:xfrm>
+          <a:prstGeom prst="rect">
+            <a:avLst/>
+          </a:prstGeom>
+        </p:spPr>
+      </p:pic>
     </p:spTree>
   </p:cSld>
   <p:clrMapOvr>
@@ -4377,7 +4878,7 @@
 </file>
 
 <file path=ppt/slides/slide13.xml><?xml version="1.0" encoding="utf-8"?>
-<p:sld xmlns:a="http://schemas.openxmlformats.org/drawingml/2006/main" xmlns:p="http://schemas.openxmlformats.org/presentationml/2006/main" xmlns:r="http://schemas.openxmlformats.org/officeDocument/2006/relationships">
+<p:sld xmlns:a="http://schemas.openxmlformats.org/drawingml/2006/main" xmlns:r="http://schemas.openxmlformats.org/officeDocument/2006/relationships" xmlns:p="http://schemas.openxmlformats.org/presentationml/2006/main">
   <p:cSld>
     <p:spTree>
       <p:nvGrpSpPr>
@@ -4385,7 +4886,14 @@
         <p:cNvGrpSpPr/>
         <p:nvPr/>
       </p:nvGrpSpPr>
-      <p:grpSpPr/>
+      <p:grpSpPr>
+        <a:xfrm>
+          <a:off x="0" y="0"/>
+          <a:ext cx="0" cy="0"/>
+          <a:chOff x="0" y="0"/>
+          <a:chExt cx="0" cy="0"/>
+        </a:xfrm>
+      </p:grpSpPr>
       <p:sp>
         <p:nvSpPr>
           <p:cNvPr id="2" name="Rectangle 1"/>
@@ -4427,6 +4935,7 @@
           <a:lstStyle/>
           <a:p>
             <a:pPr algn="ctr"/>
+            <a:endParaRPr/>
           </a:p>
         </p:txBody>
       </p:sp>
@@ -4471,6 +4980,7 @@
           <a:lstStyle/>
           <a:p>
             <a:pPr algn="ctr"/>
+            <a:endParaRPr/>
           </a:p>
         </p:txBody>
       </p:sp>
@@ -4491,7 +5001,7 @@
           <a:noFill/>
         </p:spPr>
         <p:txBody>
-          <a:bodyPr wrap="square" anchor="ctr" lIns="45720" rIns="45720" tIns="27432" bIns="27432">
+          <a:bodyPr wrap="square" lIns="45720" tIns="27432" rIns="45720" bIns="27432" anchor="ctr">
             <a:spAutoFit/>
           </a:bodyPr>
           <a:lstStyle/>
@@ -4524,7 +5034,7 @@
 </file>
 
 <file path=ppt/slides/slide14.xml><?xml version="1.0" encoding="utf-8"?>
-<p:sld xmlns:a="http://schemas.openxmlformats.org/drawingml/2006/main" xmlns:p="http://schemas.openxmlformats.org/presentationml/2006/main" xmlns:r="http://schemas.openxmlformats.org/officeDocument/2006/relationships">
+<p:sld xmlns:a="http://schemas.openxmlformats.org/drawingml/2006/main" xmlns:r="http://schemas.openxmlformats.org/officeDocument/2006/relationships" xmlns:p="http://schemas.openxmlformats.org/presentationml/2006/main">
   <p:cSld>
     <p:spTree>
       <p:nvGrpSpPr>
@@ -4532,7 +5042,14 @@
         <p:cNvGrpSpPr/>
         <p:nvPr/>
       </p:nvGrpSpPr>
-      <p:grpSpPr/>
+      <p:grpSpPr>
+        <a:xfrm>
+          <a:off x="0" y="0"/>
+          <a:ext cx="0" cy="0"/>
+          <a:chOff x="0" y="0"/>
+          <a:chExt cx="0" cy="0"/>
+        </a:xfrm>
+      </p:grpSpPr>
       <p:sp>
         <p:nvSpPr>
           <p:cNvPr id="2" name="Rectangle 1"/>
@@ -4574,6 +5091,7 @@
           <a:lstStyle/>
           <a:p>
             <a:pPr algn="ctr"/>
+            <a:endParaRPr/>
           </a:p>
         </p:txBody>
       </p:sp>
@@ -4618,6 +5136,7 @@
           <a:lstStyle/>
           <a:p>
             <a:pPr algn="ctr"/>
+            <a:endParaRPr/>
           </a:p>
         </p:txBody>
       </p:sp>
@@ -4638,7 +5157,7 @@
           <a:noFill/>
         </p:spPr>
         <p:txBody>
-          <a:bodyPr wrap="square" anchor="t" lIns="45720" rIns="45720" tIns="27432" bIns="27432">
+          <a:bodyPr wrap="square" lIns="45720" tIns="27432" rIns="45720" bIns="27432" anchor="t">
             <a:spAutoFit/>
           </a:bodyPr>
           <a:lstStyle/>
@@ -4679,7 +5198,7 @@
           <a:noFill/>
         </p:spPr>
         <p:txBody>
-          <a:bodyPr wrap="square" anchor="t" lIns="45720" rIns="45720" tIns="27432" bIns="27432">
+          <a:bodyPr wrap="square" lIns="45720" tIns="27432" rIns="45720" bIns="27432" anchor="t">
             <a:spAutoFit/>
           </a:bodyPr>
           <a:lstStyle/>
@@ -4782,6 +5301,7 @@
           <a:lstStyle/>
           <a:p>
             <a:pPr algn="ctr"/>
+            <a:endParaRPr/>
           </a:p>
         </p:txBody>
       </p:sp>
@@ -4802,7 +5322,7 @@
           <a:noFill/>
         </p:spPr>
         <p:txBody>
-          <a:bodyPr wrap="square" anchor="ctr" lIns="45720" rIns="45720" tIns="27432" bIns="27432">
+          <a:bodyPr wrap="square" lIns="45720" tIns="27432" rIns="45720" bIns="27432" anchor="ctr">
             <a:spAutoFit/>
           </a:bodyPr>
           <a:lstStyle/>
@@ -4843,7 +5363,7 @@
           <a:noFill/>
         </p:spPr>
         <p:txBody>
-          <a:bodyPr wrap="square" anchor="ctr" lIns="45720" rIns="45720" tIns="27432" bIns="27432">
+          <a:bodyPr wrap="square" lIns="45720" tIns="27432" rIns="45720" bIns="27432" anchor="ctr">
             <a:spAutoFit/>
           </a:bodyPr>
           <a:lstStyle/>
@@ -4867,6 +5387,36 @@
           </a:p>
         </p:txBody>
       </p:sp>
+      <p:pic>
+        <p:nvPicPr>
+          <p:cNvPr id="9" name="그림 8" descr="텍스트, 스크린샷, 폰트, 번호이(가) 표시된 사진&#10;&#10;AI 생성 콘텐츠는 정확하지 않을 수 있습니다.">
+            <a:extLst>
+              <a:ext uri="{FF2B5EF4-FFF2-40B4-BE49-F238E27FC236}">
+                <a16:creationId xmlns:a16="http://schemas.microsoft.com/office/drawing/2014/main" id="{EB248AA3-ABC7-683F-FEB9-B9139FF86C1F}"/>
+              </a:ext>
+            </a:extLst>
+          </p:cNvPr>
+          <p:cNvPicPr>
+            <a:picLocks noChangeAspect="1"/>
+          </p:cNvPicPr>
+          <p:nvPr/>
+        </p:nvPicPr>
+        <p:blipFill>
+          <a:blip r:embed="rId2"/>
+          <a:stretch>
+            <a:fillRect/>
+          </a:stretch>
+        </p:blipFill>
+        <p:spPr>
+          <a:xfrm>
+            <a:off x="7770176" y="0"/>
+            <a:ext cx="3751263" cy="6858000"/>
+          </a:xfrm>
+          <a:prstGeom prst="rect">
+            <a:avLst/>
+          </a:prstGeom>
+        </p:spPr>
+      </p:pic>
     </p:spTree>
   </p:cSld>
   <p:clrMapOvr>
@@ -4876,7 +5426,7 @@
 </file>
 
 <file path=ppt/slides/slide15.xml><?xml version="1.0" encoding="utf-8"?>
-<p:sld xmlns:a="http://schemas.openxmlformats.org/drawingml/2006/main" xmlns:p="http://schemas.openxmlformats.org/presentationml/2006/main" xmlns:r="http://schemas.openxmlformats.org/officeDocument/2006/relationships">
+<p:sld xmlns:a="http://schemas.openxmlformats.org/drawingml/2006/main" xmlns:r="http://schemas.openxmlformats.org/officeDocument/2006/relationships" xmlns:p="http://schemas.openxmlformats.org/presentationml/2006/main">
   <p:cSld>
     <p:spTree>
       <p:nvGrpSpPr>
@@ -4884,7 +5434,14 @@
         <p:cNvGrpSpPr/>
         <p:nvPr/>
       </p:nvGrpSpPr>
-      <p:grpSpPr/>
+      <p:grpSpPr>
+        <a:xfrm>
+          <a:off x="0" y="0"/>
+          <a:ext cx="0" cy="0"/>
+          <a:chOff x="0" y="0"/>
+          <a:chExt cx="0" cy="0"/>
+        </a:xfrm>
+      </p:grpSpPr>
       <p:sp>
         <p:nvSpPr>
           <p:cNvPr id="2" name="Rectangle 1"/>
@@ -4926,6 +5483,7 @@
           <a:lstStyle/>
           <a:p>
             <a:pPr algn="ctr"/>
+            <a:endParaRPr/>
           </a:p>
         </p:txBody>
       </p:sp>
@@ -4970,6 +5528,7 @@
           <a:lstStyle/>
           <a:p>
             <a:pPr algn="ctr"/>
+            <a:endParaRPr/>
           </a:p>
         </p:txBody>
       </p:sp>
@@ -4990,7 +5549,7 @@
           <a:noFill/>
         </p:spPr>
         <p:txBody>
-          <a:bodyPr wrap="square" anchor="t" lIns="45720" rIns="45720" tIns="27432" bIns="27432">
+          <a:bodyPr wrap="square" lIns="45720" tIns="27432" rIns="45720" bIns="27432" anchor="t">
             <a:spAutoFit/>
           </a:bodyPr>
           <a:lstStyle/>
@@ -5031,7 +5590,7 @@
           <a:noFill/>
         </p:spPr>
         <p:txBody>
-          <a:bodyPr wrap="square" anchor="t" lIns="45720" rIns="45720" tIns="27432" bIns="27432">
+          <a:bodyPr wrap="square" lIns="45720" tIns="27432" rIns="45720" bIns="27432" anchor="t">
             <a:spAutoFit/>
           </a:bodyPr>
           <a:lstStyle/>
@@ -5152,6 +5711,7 @@
           <a:lstStyle/>
           <a:p>
             <a:pPr algn="ctr"/>
+            <a:endParaRPr/>
           </a:p>
         </p:txBody>
       </p:sp>
@@ -5172,7 +5732,7 @@
           <a:noFill/>
         </p:spPr>
         <p:txBody>
-          <a:bodyPr wrap="square" anchor="ctr" lIns="45720" rIns="45720" tIns="27432" bIns="27432">
+          <a:bodyPr wrap="square" lIns="45720" tIns="27432" rIns="45720" bIns="27432" anchor="ctr">
             <a:spAutoFit/>
           </a:bodyPr>
           <a:lstStyle/>
@@ -5213,7 +5773,7 @@
           <a:noFill/>
         </p:spPr>
         <p:txBody>
-          <a:bodyPr wrap="square" anchor="ctr" lIns="45720" rIns="45720" tIns="27432" bIns="27432">
+          <a:bodyPr wrap="square" lIns="45720" tIns="27432" rIns="45720" bIns="27432" anchor="ctr">
             <a:spAutoFit/>
           </a:bodyPr>
           <a:lstStyle/>
@@ -5237,6 +5797,36 @@
           </a:p>
         </p:txBody>
       </p:sp>
+      <p:pic>
+        <p:nvPicPr>
+          <p:cNvPr id="9" name="그림 8" descr="텍스트, 스크린샷, 폰트, 번호이(가) 표시된 사진&#10;&#10;AI 생성 콘텐츠는 정확하지 않을 수 있습니다.">
+            <a:extLst>
+              <a:ext uri="{FF2B5EF4-FFF2-40B4-BE49-F238E27FC236}">
+                <a16:creationId xmlns:a16="http://schemas.microsoft.com/office/drawing/2014/main" id="{F30D1F8C-93CD-5E05-1600-47E385B42666}"/>
+              </a:ext>
+            </a:extLst>
+          </p:cNvPr>
+          <p:cNvPicPr>
+            <a:picLocks noChangeAspect="1"/>
+          </p:cNvPicPr>
+          <p:nvPr/>
+        </p:nvPicPr>
+        <p:blipFill>
+          <a:blip r:embed="rId2"/>
+          <a:stretch>
+            <a:fillRect/>
+          </a:stretch>
+        </p:blipFill>
+        <p:spPr>
+          <a:xfrm>
+            <a:off x="7760036" y="0"/>
+            <a:ext cx="3761403" cy="6858000"/>
+          </a:xfrm>
+          <a:prstGeom prst="rect">
+            <a:avLst/>
+          </a:prstGeom>
+        </p:spPr>
+      </p:pic>
     </p:spTree>
   </p:cSld>
   <p:clrMapOvr>
@@ -5246,7 +5836,7 @@
 </file>
 
 <file path=ppt/slides/slide16.xml><?xml version="1.0" encoding="utf-8"?>
-<p:sld xmlns:a="http://schemas.openxmlformats.org/drawingml/2006/main" xmlns:p="http://schemas.openxmlformats.org/presentationml/2006/main" xmlns:r="http://schemas.openxmlformats.org/officeDocument/2006/relationships">
+<p:sld xmlns:a="http://schemas.openxmlformats.org/drawingml/2006/main" xmlns:r="http://schemas.openxmlformats.org/officeDocument/2006/relationships" xmlns:p="http://schemas.openxmlformats.org/presentationml/2006/main">
   <p:cSld>
     <p:spTree>
       <p:nvGrpSpPr>
@@ -5254,7 +5844,14 @@
         <p:cNvGrpSpPr/>
         <p:nvPr/>
       </p:nvGrpSpPr>
-      <p:grpSpPr/>
+      <p:grpSpPr>
+        <a:xfrm>
+          <a:off x="0" y="0"/>
+          <a:ext cx="0" cy="0"/>
+          <a:chOff x="0" y="0"/>
+          <a:chExt cx="0" cy="0"/>
+        </a:xfrm>
+      </p:grpSpPr>
       <p:sp>
         <p:nvSpPr>
           <p:cNvPr id="2" name="Rectangle 1"/>
@@ -5296,6 +5893,7 @@
           <a:lstStyle/>
           <a:p>
             <a:pPr algn="ctr"/>
+            <a:endParaRPr/>
           </a:p>
         </p:txBody>
       </p:sp>
@@ -5340,6 +5938,7 @@
           <a:lstStyle/>
           <a:p>
             <a:pPr algn="ctr"/>
+            <a:endParaRPr/>
           </a:p>
         </p:txBody>
       </p:sp>
@@ -5360,7 +5959,7 @@
           <a:noFill/>
         </p:spPr>
         <p:txBody>
-          <a:bodyPr wrap="square" anchor="t" lIns="45720" rIns="45720" tIns="27432" bIns="27432">
+          <a:bodyPr wrap="square" lIns="45720" tIns="27432" rIns="45720" bIns="27432" anchor="t">
             <a:spAutoFit/>
           </a:bodyPr>
           <a:lstStyle/>
@@ -5401,7 +6000,7 @@
           <a:noFill/>
         </p:spPr>
         <p:txBody>
-          <a:bodyPr wrap="square" anchor="t" lIns="45720" rIns="45720" tIns="27432" bIns="27432">
+          <a:bodyPr wrap="square" lIns="45720" tIns="27432" rIns="45720" bIns="27432" anchor="t">
             <a:spAutoFit/>
           </a:bodyPr>
           <a:lstStyle/>
@@ -5412,7 +6011,7 @@
               </a:spcAft>
             </a:pPr>
             <a:r>
-              <a:rPr sz="1900" b="0">
+              <a:rPr sz="1900" b="0" dirty="0">
                 <a:solidFill>
                   <a:srgbClr val="1C1C1A"/>
                 </a:solidFill>
@@ -5420,8 +6019,49 @@
                 <a:ea typeface="PingFang SC"/>
                 <a:cs typeface="PingFang SC"/>
               </a:rPr>
-              <a:t>①  打开日程 → 进入分配</a:t>
-            </a:r>
+              <a:t>①  </a:t>
+            </a:r>
+            <a:r>
+              <a:rPr sz="1900" b="0" dirty="0" err="1">
+                <a:solidFill>
+                  <a:srgbClr val="1C1C1A"/>
+                </a:solidFill>
+                <a:latin typeface="PingFang SC"/>
+                <a:ea typeface="PingFang SC"/>
+                <a:cs typeface="PingFang SC"/>
+              </a:rPr>
+              <a:t>打开日程</a:t>
+            </a:r>
+            <a:r>
+              <a:rPr sz="1900" b="0" dirty="0">
+                <a:solidFill>
+                  <a:srgbClr val="1C1C1A"/>
+                </a:solidFill>
+                <a:latin typeface="PingFang SC"/>
+                <a:ea typeface="PingFang SC"/>
+                <a:cs typeface="PingFang SC"/>
+              </a:rPr>
+              <a:t> → </a:t>
+            </a:r>
+            <a:r>
+              <a:rPr sz="1900" b="0" dirty="0" err="1">
+                <a:solidFill>
+                  <a:srgbClr val="1C1C1A"/>
+                </a:solidFill>
+                <a:latin typeface="PingFang SC"/>
+                <a:ea typeface="PingFang SC"/>
+                <a:cs typeface="PingFang SC"/>
+              </a:rPr>
+              <a:t>进入分配</a:t>
+            </a:r>
+            <a:endParaRPr sz="1900" b="0" dirty="0">
+              <a:solidFill>
+                <a:srgbClr val="1C1C1A"/>
+              </a:solidFill>
+              <a:latin typeface="PingFang SC"/>
+              <a:ea typeface="PingFang SC"/>
+              <a:cs typeface="PingFang SC"/>
+            </a:endParaRPr>
           </a:p>
           <a:p>
             <a:pPr algn="l">
@@ -5430,7 +6070,7 @@
               </a:spcAft>
             </a:pPr>
             <a:r>
-              <a:rPr sz="1900" b="0">
+              <a:rPr sz="1900" b="0" dirty="0">
                 <a:solidFill>
                   <a:srgbClr val="1C1C1A"/>
                 </a:solidFill>
@@ -5438,8 +6078,27 @@
                 <a:ea typeface="PingFang SC"/>
                 <a:cs typeface="PingFang SC"/>
               </a:rPr>
-              <a:t>②  选人“组队”建立队伍</a:t>
-            </a:r>
+              <a:t>②  </a:t>
+            </a:r>
+            <a:r>
+              <a:rPr sz="1900" b="0" dirty="0" err="1">
+                <a:solidFill>
+                  <a:srgbClr val="1C1C1A"/>
+                </a:solidFill>
+                <a:latin typeface="PingFang SC"/>
+                <a:ea typeface="PingFang SC"/>
+                <a:cs typeface="PingFang SC"/>
+              </a:rPr>
+              <a:t>选人“组队”建立队伍</a:t>
+            </a:r>
+            <a:endParaRPr sz="1900" b="0" dirty="0">
+              <a:solidFill>
+                <a:srgbClr val="1C1C1A"/>
+              </a:solidFill>
+              <a:latin typeface="PingFang SC"/>
+              <a:ea typeface="PingFang SC"/>
+              <a:cs typeface="PingFang SC"/>
+            </a:endParaRPr>
           </a:p>
           <a:p>
             <a:pPr algn="l">
@@ -5448,7 +6107,7 @@
               </a:spcAft>
             </a:pPr>
             <a:r>
-              <a:rPr sz="1900" b="0">
+              <a:rPr sz="1900" b="0" dirty="0">
                 <a:solidFill>
                   <a:srgbClr val="1C1C1A"/>
                 </a:solidFill>
@@ -5456,8 +6115,49 @@
                 <a:ea typeface="PingFang SC"/>
                 <a:cs typeface="PingFang SC"/>
               </a:rPr>
-              <a:t>③  点队伍的 › 分配地区</a:t>
-            </a:r>
+              <a:t>③  </a:t>
+            </a:r>
+            <a:r>
+              <a:rPr sz="1900" b="0" dirty="0" err="1">
+                <a:solidFill>
+                  <a:srgbClr val="1C1C1A"/>
+                </a:solidFill>
+                <a:latin typeface="PingFang SC"/>
+                <a:ea typeface="PingFang SC"/>
+                <a:cs typeface="PingFang SC"/>
+              </a:rPr>
+              <a:t>点队伍的</a:t>
+            </a:r>
+            <a:r>
+              <a:rPr sz="1900" b="0" dirty="0">
+                <a:solidFill>
+                  <a:srgbClr val="1C1C1A"/>
+                </a:solidFill>
+                <a:latin typeface="PingFang SC"/>
+                <a:ea typeface="PingFang SC"/>
+                <a:cs typeface="PingFang SC"/>
+              </a:rPr>
+              <a:t> › </a:t>
+            </a:r>
+            <a:r>
+              <a:rPr sz="1900" b="0" dirty="0" err="1">
+                <a:solidFill>
+                  <a:srgbClr val="1C1C1A"/>
+                </a:solidFill>
+                <a:latin typeface="PingFang SC"/>
+                <a:ea typeface="PingFang SC"/>
+                <a:cs typeface="PingFang SC"/>
+              </a:rPr>
+              <a:t>分配地区</a:t>
+            </a:r>
+            <a:endParaRPr sz="1900" b="0" dirty="0">
+              <a:solidFill>
+                <a:srgbClr val="1C1C1A"/>
+              </a:solidFill>
+              <a:latin typeface="PingFang SC"/>
+              <a:ea typeface="PingFang SC"/>
+              <a:cs typeface="PingFang SC"/>
+            </a:endParaRPr>
           </a:p>
           <a:p>
             <a:pPr algn="l">
@@ -5466,7 +6166,7 @@
               </a:spcAft>
             </a:pPr>
             <a:r>
-              <a:rPr sz="1900" b="0">
+              <a:rPr sz="1900" b="0" dirty="0">
                 <a:solidFill>
                   <a:srgbClr val="1C1C1A"/>
                 </a:solidFill>
@@ -5474,7 +6174,29 @@
                 <a:ea typeface="PingFang SC"/>
                 <a:cs typeface="PingFang SC"/>
               </a:rPr>
-              <a:t>④  最后点“分享分配”</a:t>
+              <a:t>④  </a:t>
+            </a:r>
+            <a:r>
+              <a:rPr sz="1900" b="0" dirty="0" err="1">
+                <a:solidFill>
+                  <a:srgbClr val="1C1C1A"/>
+                </a:solidFill>
+                <a:latin typeface="PingFang SC"/>
+                <a:ea typeface="PingFang SC"/>
+                <a:cs typeface="PingFang SC"/>
+              </a:rPr>
+              <a:t>最后点“分享分配</a:t>
+            </a:r>
+            <a:r>
+              <a:rPr sz="1900" b="0" dirty="0">
+                <a:solidFill>
+                  <a:srgbClr val="1C1C1A"/>
+                </a:solidFill>
+                <a:latin typeface="PingFang SC"/>
+                <a:ea typeface="PingFang SC"/>
+                <a:cs typeface="PingFang SC"/>
+              </a:rPr>
+              <a:t>”</a:t>
             </a:r>
           </a:p>
           <a:p>
@@ -5484,7 +6206,7 @@
               </a:spcAft>
             </a:pPr>
             <a:r>
-              <a:rPr sz="1600" b="0">
+              <a:rPr sz="1600" b="0" dirty="0">
                 <a:solidFill>
                   <a:srgbClr val="B45A09"/>
                 </a:solidFill>
@@ -5492,7 +6214,29 @@
                 <a:ea typeface="PingFang SC"/>
                 <a:cs typeface="PingFang SC"/>
               </a:rPr>
-              <a:t>💡 分享后队员才会收到通知。</a:t>
+              <a:t>💡 </a:t>
+            </a:r>
+            <a:r>
+              <a:rPr sz="1600" b="0" dirty="0" err="1">
+                <a:solidFill>
+                  <a:srgbClr val="B45A09"/>
+                </a:solidFill>
+                <a:latin typeface="PingFang SC"/>
+                <a:ea typeface="PingFang SC"/>
+                <a:cs typeface="PingFang SC"/>
+              </a:rPr>
+              <a:t>分享后队员才会收到通知</a:t>
+            </a:r>
+            <a:r>
+              <a:rPr sz="1600" b="0" dirty="0">
+                <a:solidFill>
+                  <a:srgbClr val="B45A09"/>
+                </a:solidFill>
+                <a:latin typeface="PingFang SC"/>
+                <a:ea typeface="PingFang SC"/>
+                <a:cs typeface="PingFang SC"/>
+              </a:rPr>
+              <a:t>。</a:t>
             </a:r>
           </a:p>
           <a:p>
@@ -5502,7 +6246,7 @@
               </a:spcAft>
             </a:pPr>
             <a:r>
-              <a:rPr sz="1600" b="0">
+              <a:rPr sz="1600" b="0" dirty="0">
                 <a:solidFill>
                   <a:srgbClr val="B45A09"/>
                 </a:solidFill>
@@ -5510,7 +6254,29 @@
                 <a:ea typeface="PingFang SC"/>
                 <a:cs typeface="PingFang SC"/>
               </a:rPr>
-              <a:t>💡 人多时可用搜索。</a:t>
+              <a:t>💡 </a:t>
+            </a:r>
+            <a:r>
+              <a:rPr sz="1600" b="0" dirty="0" err="1">
+                <a:solidFill>
+                  <a:srgbClr val="B45A09"/>
+                </a:solidFill>
+                <a:latin typeface="PingFang SC"/>
+                <a:ea typeface="PingFang SC"/>
+                <a:cs typeface="PingFang SC"/>
+              </a:rPr>
+              <a:t>人多时可用搜索</a:t>
+            </a:r>
+            <a:r>
+              <a:rPr sz="1600" b="0" dirty="0">
+                <a:solidFill>
+                  <a:srgbClr val="B45A09"/>
+                </a:solidFill>
+                <a:latin typeface="PingFang SC"/>
+                <a:ea typeface="PingFang SC"/>
+                <a:cs typeface="PingFang SC"/>
+              </a:rPr>
+              <a:t>。</a:t>
             </a:r>
           </a:p>
         </p:txBody>
@@ -5558,6 +6324,7 @@
           <a:lstStyle/>
           <a:p>
             <a:pPr algn="ctr"/>
+            <a:endParaRPr/>
           </a:p>
         </p:txBody>
       </p:sp>
@@ -5578,7 +6345,7 @@
           <a:noFill/>
         </p:spPr>
         <p:txBody>
-          <a:bodyPr wrap="square" anchor="ctr" lIns="45720" rIns="45720" tIns="27432" bIns="27432">
+          <a:bodyPr wrap="square" lIns="45720" tIns="27432" rIns="45720" bIns="27432" anchor="ctr">
             <a:spAutoFit/>
           </a:bodyPr>
           <a:lstStyle/>
@@ -5619,7 +6386,7 @@
           <a:noFill/>
         </p:spPr>
         <p:txBody>
-          <a:bodyPr wrap="square" anchor="ctr" lIns="45720" rIns="45720" tIns="27432" bIns="27432">
+          <a:bodyPr wrap="square" lIns="45720" tIns="27432" rIns="45720" bIns="27432" anchor="ctr">
             <a:spAutoFit/>
           </a:bodyPr>
           <a:lstStyle/>
@@ -5652,7 +6419,7 @@
 </file>
 
 <file path=ppt/slides/slide17.xml><?xml version="1.0" encoding="utf-8"?>
-<p:sld xmlns:a="http://schemas.openxmlformats.org/drawingml/2006/main" xmlns:p="http://schemas.openxmlformats.org/presentationml/2006/main" xmlns:r="http://schemas.openxmlformats.org/officeDocument/2006/relationships">
+<p:sld xmlns:a="http://schemas.openxmlformats.org/drawingml/2006/main" xmlns:r="http://schemas.openxmlformats.org/officeDocument/2006/relationships" xmlns:p="http://schemas.openxmlformats.org/presentationml/2006/main">
   <p:cSld>
     <p:spTree>
       <p:nvGrpSpPr>
@@ -5660,7 +6427,14 @@
         <p:cNvGrpSpPr/>
         <p:nvPr/>
       </p:nvGrpSpPr>
-      <p:grpSpPr/>
+      <p:grpSpPr>
+        <a:xfrm>
+          <a:off x="0" y="0"/>
+          <a:ext cx="0" cy="0"/>
+          <a:chOff x="0" y="0"/>
+          <a:chExt cx="0" cy="0"/>
+        </a:xfrm>
+      </p:grpSpPr>
       <p:sp>
         <p:nvSpPr>
           <p:cNvPr id="2" name="Rectangle 1"/>
@@ -5702,6 +6476,7 @@
           <a:lstStyle/>
           <a:p>
             <a:pPr algn="ctr"/>
+            <a:endParaRPr/>
           </a:p>
         </p:txBody>
       </p:sp>
@@ -5746,6 +6521,7 @@
           <a:lstStyle/>
           <a:p>
             <a:pPr algn="ctr"/>
+            <a:endParaRPr/>
           </a:p>
         </p:txBody>
       </p:sp>
@@ -5766,7 +6542,7 @@
           <a:noFill/>
         </p:spPr>
         <p:txBody>
-          <a:bodyPr wrap="square" anchor="t" lIns="45720" rIns="45720" tIns="27432" bIns="27432">
+          <a:bodyPr wrap="square" lIns="45720" tIns="27432" rIns="45720" bIns="27432" anchor="t">
             <a:spAutoFit/>
           </a:bodyPr>
           <a:lstStyle/>
@@ -5807,7 +6583,7 @@
           <a:noFill/>
         </p:spPr>
         <p:txBody>
-          <a:bodyPr wrap="square" anchor="t" lIns="45720" rIns="45720" tIns="27432" bIns="27432">
+          <a:bodyPr wrap="square" lIns="45720" tIns="27432" rIns="45720" bIns="27432" anchor="t">
             <a:spAutoFit/>
           </a:bodyPr>
           <a:lstStyle/>
@@ -5910,6 +6686,7 @@
           <a:lstStyle/>
           <a:p>
             <a:pPr algn="ctr"/>
+            <a:endParaRPr/>
           </a:p>
         </p:txBody>
       </p:sp>
@@ -5930,7 +6707,7 @@
           <a:noFill/>
         </p:spPr>
         <p:txBody>
-          <a:bodyPr wrap="square" anchor="ctr" lIns="45720" rIns="45720" tIns="27432" bIns="27432">
+          <a:bodyPr wrap="square" lIns="45720" tIns="27432" rIns="45720" bIns="27432" anchor="ctr">
             <a:spAutoFit/>
           </a:bodyPr>
           <a:lstStyle/>
@@ -5971,7 +6748,7 @@
           <a:noFill/>
         </p:spPr>
         <p:txBody>
-          <a:bodyPr wrap="square" anchor="ctr" lIns="45720" rIns="45720" tIns="27432" bIns="27432">
+          <a:bodyPr wrap="square" lIns="45720" tIns="27432" rIns="45720" bIns="27432" anchor="ctr">
             <a:spAutoFit/>
           </a:bodyPr>
           <a:lstStyle/>
@@ -5995,6 +6772,36 @@
           </a:p>
         </p:txBody>
       </p:sp>
+      <p:pic>
+        <p:nvPicPr>
+          <p:cNvPr id="9" name="그림 8" descr="텍스트, 스크린샷, 폰트, 번호이(가) 표시된 사진&#10;&#10;AI 생성 콘텐츠는 정확하지 않을 수 있습니다.">
+            <a:extLst>
+              <a:ext uri="{FF2B5EF4-FFF2-40B4-BE49-F238E27FC236}">
+                <a16:creationId xmlns:a16="http://schemas.microsoft.com/office/drawing/2014/main" id="{DEB06635-EB86-2B30-BE19-0CD6294DA105}"/>
+              </a:ext>
+            </a:extLst>
+          </p:cNvPr>
+          <p:cNvPicPr>
+            <a:picLocks noChangeAspect="1"/>
+          </p:cNvPicPr>
+          <p:nvPr/>
+        </p:nvPicPr>
+        <p:blipFill>
+          <a:blip r:embed="rId2"/>
+          <a:stretch>
+            <a:fillRect/>
+          </a:stretch>
+        </p:blipFill>
+        <p:spPr>
+          <a:xfrm>
+            <a:off x="7866566" y="0"/>
+            <a:ext cx="3726546" cy="6858000"/>
+          </a:xfrm>
+          <a:prstGeom prst="rect">
+            <a:avLst/>
+          </a:prstGeom>
+        </p:spPr>
+      </p:pic>
     </p:spTree>
   </p:cSld>
   <p:clrMapOvr>
@@ -6004,7 +6811,7 @@
 </file>
 
 <file path=ppt/slides/slide18.xml><?xml version="1.0" encoding="utf-8"?>
-<p:sld xmlns:a="http://schemas.openxmlformats.org/drawingml/2006/main" xmlns:p="http://schemas.openxmlformats.org/presentationml/2006/main" xmlns:r="http://schemas.openxmlformats.org/officeDocument/2006/relationships">
+<p:sld xmlns:a="http://schemas.openxmlformats.org/drawingml/2006/main" xmlns:r="http://schemas.openxmlformats.org/officeDocument/2006/relationships" xmlns:p="http://schemas.openxmlformats.org/presentationml/2006/main">
   <p:cSld>
     <p:spTree>
       <p:nvGrpSpPr>
@@ -6012,7 +6819,14 @@
         <p:cNvGrpSpPr/>
         <p:nvPr/>
       </p:nvGrpSpPr>
-      <p:grpSpPr/>
+      <p:grpSpPr>
+        <a:xfrm>
+          <a:off x="0" y="0"/>
+          <a:ext cx="0" cy="0"/>
+          <a:chOff x="0" y="0"/>
+          <a:chExt cx="0" cy="0"/>
+        </a:xfrm>
+      </p:grpSpPr>
       <p:sp>
         <p:nvSpPr>
           <p:cNvPr id="2" name="Rectangle 1"/>
@@ -6054,6 +6868,7 @@
           <a:lstStyle/>
           <a:p>
             <a:pPr algn="ctr"/>
+            <a:endParaRPr/>
           </a:p>
         </p:txBody>
       </p:sp>
@@ -6098,6 +6913,7 @@
           <a:lstStyle/>
           <a:p>
             <a:pPr algn="ctr"/>
+            <a:endParaRPr/>
           </a:p>
         </p:txBody>
       </p:sp>
@@ -6118,7 +6934,7 @@
           <a:noFill/>
         </p:spPr>
         <p:txBody>
-          <a:bodyPr wrap="square" anchor="ctr" lIns="45720" rIns="45720" tIns="27432" bIns="27432">
+          <a:bodyPr wrap="square" lIns="45720" tIns="27432" rIns="45720" bIns="27432" anchor="ctr">
             <a:spAutoFit/>
           </a:bodyPr>
           <a:lstStyle/>
@@ -6151,7 +6967,7 @@
 </file>
 
 <file path=ppt/slides/slide19.xml><?xml version="1.0" encoding="utf-8"?>
-<p:sld xmlns:a="http://schemas.openxmlformats.org/drawingml/2006/main" xmlns:p="http://schemas.openxmlformats.org/presentationml/2006/main" xmlns:r="http://schemas.openxmlformats.org/officeDocument/2006/relationships">
+<p:sld xmlns:a="http://schemas.openxmlformats.org/drawingml/2006/main" xmlns:r="http://schemas.openxmlformats.org/officeDocument/2006/relationships" xmlns:p="http://schemas.openxmlformats.org/presentationml/2006/main">
   <p:cSld>
     <p:spTree>
       <p:nvGrpSpPr>
@@ -6159,7 +6975,14 @@
         <p:cNvGrpSpPr/>
         <p:nvPr/>
       </p:nvGrpSpPr>
-      <p:grpSpPr/>
+      <p:grpSpPr>
+        <a:xfrm>
+          <a:off x="0" y="0"/>
+          <a:ext cx="0" cy="0"/>
+          <a:chOff x="0" y="0"/>
+          <a:chExt cx="0" cy="0"/>
+        </a:xfrm>
+      </p:grpSpPr>
       <p:sp>
         <p:nvSpPr>
           <p:cNvPr id="2" name="Rectangle 1"/>
@@ -6201,6 +7024,7 @@
           <a:lstStyle/>
           <a:p>
             <a:pPr algn="ctr"/>
+            <a:endParaRPr/>
           </a:p>
         </p:txBody>
       </p:sp>
@@ -6245,6 +7069,7 @@
           <a:lstStyle/>
           <a:p>
             <a:pPr algn="ctr"/>
+            <a:endParaRPr/>
           </a:p>
         </p:txBody>
       </p:sp>
@@ -6265,7 +7090,7 @@
           <a:noFill/>
         </p:spPr>
         <p:txBody>
-          <a:bodyPr wrap="square" anchor="t" lIns="45720" rIns="45720" tIns="27432" bIns="27432">
+          <a:bodyPr wrap="square" lIns="45720" tIns="27432" rIns="45720" bIns="27432" anchor="t">
             <a:spAutoFit/>
           </a:bodyPr>
           <a:lstStyle/>
@@ -6306,7 +7131,7 @@
           <a:noFill/>
         </p:spPr>
         <p:txBody>
-          <a:bodyPr wrap="square" anchor="t" lIns="45720" rIns="45720" tIns="27432" bIns="27432">
+          <a:bodyPr wrap="square" lIns="45720" tIns="27432" rIns="45720" bIns="27432" anchor="t">
             <a:spAutoFit/>
           </a:bodyPr>
           <a:lstStyle/>
@@ -6409,6 +7234,7 @@
           <a:lstStyle/>
           <a:p>
             <a:pPr algn="ctr"/>
+            <a:endParaRPr/>
           </a:p>
         </p:txBody>
       </p:sp>
@@ -6429,7 +7255,7 @@
           <a:noFill/>
         </p:spPr>
         <p:txBody>
-          <a:bodyPr wrap="square" anchor="ctr" lIns="45720" rIns="45720" tIns="27432" bIns="27432">
+          <a:bodyPr wrap="square" lIns="45720" tIns="27432" rIns="45720" bIns="27432" anchor="ctr">
             <a:spAutoFit/>
           </a:bodyPr>
           <a:lstStyle/>
@@ -6470,7 +7296,7 @@
           <a:noFill/>
         </p:spPr>
         <p:txBody>
-          <a:bodyPr wrap="square" anchor="ctr" lIns="45720" rIns="45720" tIns="27432" bIns="27432">
+          <a:bodyPr wrap="square" lIns="45720" tIns="27432" rIns="45720" bIns="27432" anchor="ctr">
             <a:spAutoFit/>
           </a:bodyPr>
           <a:lstStyle/>
@@ -6503,7 +7329,7 @@
 </file>
 
 <file path=ppt/slides/slide2.xml><?xml version="1.0" encoding="utf-8"?>
-<p:sld xmlns:a="http://schemas.openxmlformats.org/drawingml/2006/main" xmlns:p="http://schemas.openxmlformats.org/presentationml/2006/main" xmlns:r="http://schemas.openxmlformats.org/officeDocument/2006/relationships">
+<p:sld xmlns:a="http://schemas.openxmlformats.org/drawingml/2006/main" xmlns:r="http://schemas.openxmlformats.org/officeDocument/2006/relationships" xmlns:p="http://schemas.openxmlformats.org/presentationml/2006/main">
   <p:cSld>
     <p:spTree>
       <p:nvGrpSpPr>
@@ -6511,7 +7337,14 @@
         <p:cNvGrpSpPr/>
         <p:nvPr/>
       </p:nvGrpSpPr>
-      <p:grpSpPr/>
+      <p:grpSpPr>
+        <a:xfrm>
+          <a:off x="0" y="0"/>
+          <a:ext cx="0" cy="0"/>
+          <a:chOff x="0" y="0"/>
+          <a:chExt cx="0" cy="0"/>
+        </a:xfrm>
+      </p:grpSpPr>
       <p:sp>
         <p:nvSpPr>
           <p:cNvPr id="2" name="Rectangle 1"/>
@@ -6553,6 +7386,7 @@
           <a:lstStyle/>
           <a:p>
             <a:pPr algn="ctr"/>
+            <a:endParaRPr/>
           </a:p>
         </p:txBody>
       </p:sp>
@@ -6597,6 +7431,7 @@
           <a:lstStyle/>
           <a:p>
             <a:pPr algn="ctr"/>
+            <a:endParaRPr/>
           </a:p>
         </p:txBody>
       </p:sp>
@@ -6617,7 +7452,7 @@
           <a:noFill/>
         </p:spPr>
         <p:txBody>
-          <a:bodyPr wrap="square" anchor="ctr" lIns="45720" rIns="45720" tIns="27432" bIns="27432">
+          <a:bodyPr wrap="square" lIns="45720" tIns="27432" rIns="45720" bIns="27432" anchor="ctr">
             <a:spAutoFit/>
           </a:bodyPr>
           <a:lstStyle/>
@@ -6650,7 +7485,7 @@
 </file>
 
 <file path=ppt/slides/slide3.xml><?xml version="1.0" encoding="utf-8"?>
-<p:sld xmlns:a="http://schemas.openxmlformats.org/drawingml/2006/main" xmlns:p="http://schemas.openxmlformats.org/presentationml/2006/main" xmlns:r="http://schemas.openxmlformats.org/officeDocument/2006/relationships">
+<p:sld xmlns:a="http://schemas.openxmlformats.org/drawingml/2006/main" xmlns:r="http://schemas.openxmlformats.org/officeDocument/2006/relationships" xmlns:p="http://schemas.openxmlformats.org/presentationml/2006/main">
   <p:cSld>
     <p:spTree>
       <p:nvGrpSpPr>
@@ -6658,7 +7493,14 @@
         <p:cNvGrpSpPr/>
         <p:nvPr/>
       </p:nvGrpSpPr>
-      <p:grpSpPr/>
+      <p:grpSpPr>
+        <a:xfrm>
+          <a:off x="0" y="0"/>
+          <a:ext cx="0" cy="0"/>
+          <a:chOff x="0" y="0"/>
+          <a:chExt cx="0" cy="0"/>
+        </a:xfrm>
+      </p:grpSpPr>
       <p:sp>
         <p:nvSpPr>
           <p:cNvPr id="2" name="Rectangle 1"/>
@@ -6700,6 +7542,7 @@
           <a:lstStyle/>
           <a:p>
             <a:pPr algn="ctr"/>
+            <a:endParaRPr/>
           </a:p>
         </p:txBody>
       </p:sp>
@@ -6744,6 +7587,7 @@
           <a:lstStyle/>
           <a:p>
             <a:pPr algn="ctr"/>
+            <a:endParaRPr/>
           </a:p>
         </p:txBody>
       </p:sp>
@@ -6764,7 +7608,7 @@
           <a:noFill/>
         </p:spPr>
         <p:txBody>
-          <a:bodyPr wrap="square" anchor="t" lIns="45720" rIns="45720" tIns="27432" bIns="27432">
+          <a:bodyPr wrap="square" lIns="45720" tIns="27432" rIns="45720" bIns="27432" anchor="t">
             <a:spAutoFit/>
           </a:bodyPr>
           <a:lstStyle/>
@@ -6805,7 +7649,7 @@
           <a:noFill/>
         </p:spPr>
         <p:txBody>
-          <a:bodyPr wrap="square" anchor="t" lIns="45720" rIns="45720" tIns="27432" bIns="27432">
+          <a:bodyPr wrap="square" lIns="45720" tIns="27432" rIns="45720" bIns="27432" anchor="t">
             <a:spAutoFit/>
           </a:bodyPr>
           <a:lstStyle/>
@@ -6926,6 +7770,7 @@
           <a:lstStyle/>
           <a:p>
             <a:pPr algn="ctr"/>
+            <a:endParaRPr/>
           </a:p>
         </p:txBody>
       </p:sp>
@@ -6946,7 +7791,7 @@
           <a:noFill/>
         </p:spPr>
         <p:txBody>
-          <a:bodyPr wrap="square" anchor="ctr" lIns="45720" rIns="45720" tIns="27432" bIns="27432">
+          <a:bodyPr wrap="square" lIns="45720" tIns="27432" rIns="45720" bIns="27432" anchor="ctr">
             <a:spAutoFit/>
           </a:bodyPr>
           <a:lstStyle/>
@@ -6987,7 +7832,7 @@
           <a:noFill/>
         </p:spPr>
         <p:txBody>
-          <a:bodyPr wrap="square" anchor="ctr" lIns="45720" rIns="45720" tIns="27432" bIns="27432">
+          <a:bodyPr wrap="square" lIns="45720" tIns="27432" rIns="45720" bIns="27432" anchor="ctr">
             <a:spAutoFit/>
           </a:bodyPr>
           <a:lstStyle/>
@@ -7020,7 +7865,7 @@
 </file>
 
 <file path=ppt/slides/slide4.xml><?xml version="1.0" encoding="utf-8"?>
-<p:sld xmlns:a="http://schemas.openxmlformats.org/drawingml/2006/main" xmlns:p="http://schemas.openxmlformats.org/presentationml/2006/main" xmlns:r="http://schemas.openxmlformats.org/officeDocument/2006/relationships">
+<p:sld xmlns:a="http://schemas.openxmlformats.org/drawingml/2006/main" xmlns:r="http://schemas.openxmlformats.org/officeDocument/2006/relationships" xmlns:p="http://schemas.openxmlformats.org/presentationml/2006/main">
   <p:cSld>
     <p:spTree>
       <p:nvGrpSpPr>
@@ -7028,7 +7873,14 @@
         <p:cNvGrpSpPr/>
         <p:nvPr/>
       </p:nvGrpSpPr>
-      <p:grpSpPr/>
+      <p:grpSpPr>
+        <a:xfrm>
+          <a:off x="0" y="0"/>
+          <a:ext cx="0" cy="0"/>
+          <a:chOff x="0" y="0"/>
+          <a:chExt cx="0" cy="0"/>
+        </a:xfrm>
+      </p:grpSpPr>
       <p:sp>
         <p:nvSpPr>
           <p:cNvPr id="2" name="Rectangle 1"/>
@@ -7070,6 +7922,7 @@
           <a:lstStyle/>
           <a:p>
             <a:pPr algn="ctr"/>
+            <a:endParaRPr/>
           </a:p>
         </p:txBody>
       </p:sp>
@@ -7114,6 +7967,7 @@
           <a:lstStyle/>
           <a:p>
             <a:pPr algn="ctr"/>
+            <a:endParaRPr/>
           </a:p>
         </p:txBody>
       </p:sp>
@@ -7134,7 +7988,7 @@
           <a:noFill/>
         </p:spPr>
         <p:txBody>
-          <a:bodyPr wrap="square" anchor="t" lIns="45720" rIns="45720" tIns="27432" bIns="27432">
+          <a:bodyPr wrap="square" lIns="45720" tIns="27432" rIns="45720" bIns="27432" anchor="t">
             <a:spAutoFit/>
           </a:bodyPr>
           <a:lstStyle/>
@@ -7175,7 +8029,7 @@
           <a:noFill/>
         </p:spPr>
         <p:txBody>
-          <a:bodyPr wrap="square" anchor="t" lIns="45720" rIns="45720" tIns="27432" bIns="27432">
+          <a:bodyPr wrap="square" lIns="45720" tIns="27432" rIns="45720" bIns="27432" anchor="t">
             <a:spAutoFit/>
           </a:bodyPr>
           <a:lstStyle/>
@@ -7278,6 +8132,7 @@
           <a:lstStyle/>
           <a:p>
             <a:pPr algn="ctr"/>
+            <a:endParaRPr/>
           </a:p>
         </p:txBody>
       </p:sp>
@@ -7298,7 +8153,7 @@
           <a:noFill/>
         </p:spPr>
         <p:txBody>
-          <a:bodyPr wrap="square" anchor="ctr" lIns="45720" rIns="45720" tIns="27432" bIns="27432">
+          <a:bodyPr wrap="square" lIns="45720" tIns="27432" rIns="45720" bIns="27432" anchor="ctr">
             <a:spAutoFit/>
           </a:bodyPr>
           <a:lstStyle/>
@@ -7339,7 +8194,7 @@
           <a:noFill/>
         </p:spPr>
         <p:txBody>
-          <a:bodyPr wrap="square" anchor="ctr" lIns="45720" rIns="45720" tIns="27432" bIns="27432">
+          <a:bodyPr wrap="square" lIns="45720" tIns="27432" rIns="45720" bIns="27432" anchor="ctr">
             <a:spAutoFit/>
           </a:bodyPr>
           <a:lstStyle/>
@@ -7372,7 +8227,7 @@
 </file>
 
 <file path=ppt/slides/slide5.xml><?xml version="1.0" encoding="utf-8"?>
-<p:sld xmlns:a="http://schemas.openxmlformats.org/drawingml/2006/main" xmlns:p="http://schemas.openxmlformats.org/presentationml/2006/main" xmlns:r="http://schemas.openxmlformats.org/officeDocument/2006/relationships">
+<p:sld xmlns:a="http://schemas.openxmlformats.org/drawingml/2006/main" xmlns:r="http://schemas.openxmlformats.org/officeDocument/2006/relationships" xmlns:p="http://schemas.openxmlformats.org/presentationml/2006/main">
   <p:cSld>
     <p:spTree>
       <p:nvGrpSpPr>
@@ -7380,7 +8235,14 @@
         <p:cNvGrpSpPr/>
         <p:nvPr/>
       </p:nvGrpSpPr>
-      <p:grpSpPr/>
+      <p:grpSpPr>
+        <a:xfrm>
+          <a:off x="0" y="0"/>
+          <a:ext cx="0" cy="0"/>
+          <a:chOff x="0" y="0"/>
+          <a:chExt cx="0" cy="0"/>
+        </a:xfrm>
+      </p:grpSpPr>
       <p:sp>
         <p:nvSpPr>
           <p:cNvPr id="2" name="Rectangle 1"/>
@@ -7422,6 +8284,7 @@
           <a:lstStyle/>
           <a:p>
             <a:pPr algn="ctr"/>
+            <a:endParaRPr/>
           </a:p>
         </p:txBody>
       </p:sp>
@@ -7466,6 +8329,7 @@
           <a:lstStyle/>
           <a:p>
             <a:pPr algn="ctr"/>
+            <a:endParaRPr/>
           </a:p>
         </p:txBody>
       </p:sp>
@@ -7486,7 +8350,7 @@
           <a:noFill/>
         </p:spPr>
         <p:txBody>
-          <a:bodyPr wrap="square" anchor="t" lIns="45720" rIns="45720" tIns="27432" bIns="27432">
+          <a:bodyPr wrap="square" lIns="45720" tIns="27432" rIns="45720" bIns="27432" anchor="t">
             <a:spAutoFit/>
           </a:bodyPr>
           <a:lstStyle/>
@@ -7527,7 +8391,7 @@
           <a:noFill/>
         </p:spPr>
         <p:txBody>
-          <a:bodyPr wrap="square" anchor="t" lIns="45720" rIns="45720" tIns="27432" bIns="27432">
+          <a:bodyPr wrap="square" lIns="45720" tIns="27432" rIns="45720" bIns="27432" anchor="t">
             <a:spAutoFit/>
           </a:bodyPr>
           <a:lstStyle/>
@@ -7584,6 +8448,733 @@
               </a:rPr>
               <a:t>💡 下面逐个标签说明。</a:t>
             </a:r>
+          </a:p>
+        </p:txBody>
+      </p:sp>
+      <p:sp>
+        <p:nvSpPr>
+          <p:cNvPr id="7" name="TextBox 6"/>
+          <p:cNvSpPr txBox="1"/>
+          <p:nvPr/>
+        </p:nvSpPr>
+        <p:spPr>
+          <a:xfrm>
+            <a:off x="7955279" y="3657600"/>
+            <a:ext cx="3566160" cy="548640"/>
+          </a:xfrm>
+          <a:prstGeom prst="rect">
+            <a:avLst/>
+          </a:prstGeom>
+          <a:noFill/>
+        </p:spPr>
+        <p:txBody>
+          <a:bodyPr wrap="square" lIns="45720" tIns="27432" rIns="45720" bIns="27432" anchor="ctr">
+            <a:spAutoFit/>
+          </a:bodyPr>
+          <a:lstStyle/>
+          <a:p>
+            <a:pPr algn="ctr">
+              <a:spcAft>
+                <a:spcPts val="600"/>
+              </a:spcAft>
+            </a:pPr>
+            <a:r>
+              <a:rPr sz="1400" b="0">
+                <a:solidFill>
+                  <a:srgbClr val="6B7280"/>
+                </a:solidFill>
+                <a:latin typeface="PingFang SC"/>
+                <a:ea typeface="PingFang SC"/>
+                <a:cs typeface="PingFang SC"/>
+              </a:rPr>
+              <a:t>📷 放置截图</a:t>
+            </a:r>
+          </a:p>
+        </p:txBody>
+      </p:sp>
+      <p:sp>
+        <p:nvSpPr>
+          <p:cNvPr id="8" name="TextBox 7"/>
+          <p:cNvSpPr txBox="1"/>
+          <p:nvPr/>
+        </p:nvSpPr>
+        <p:spPr>
+          <a:xfrm>
+            <a:off x="7955279" y="4069080"/>
+            <a:ext cx="3566160" cy="457200"/>
+          </a:xfrm>
+          <a:prstGeom prst="rect">
+            <a:avLst/>
+          </a:prstGeom>
+          <a:noFill/>
+        </p:spPr>
+        <p:txBody>
+          <a:bodyPr wrap="square" lIns="45720" tIns="27432" rIns="45720" bIns="27432" anchor="ctr">
+            <a:spAutoFit/>
+          </a:bodyPr>
+          <a:lstStyle/>
+          <a:p>
+            <a:pPr algn="ctr">
+              <a:spcAft>
+                <a:spcPts val="600"/>
+              </a:spcAft>
+            </a:pPr>
+            <a:r>
+              <a:rPr sz="1100" b="0">
+                <a:solidFill>
+                  <a:srgbClr val="6B7280"/>
+                </a:solidFill>
+                <a:latin typeface="PingFang SC"/>
+                <a:ea typeface="PingFang SC"/>
+                <a:cs typeface="PingFang SC"/>
+              </a:rPr>
+              <a:t>底部标签栏</a:t>
+            </a:r>
+          </a:p>
+        </p:txBody>
+      </p:sp>
+      <p:pic>
+        <p:nvPicPr>
+          <p:cNvPr id="9" name="그림 8" descr="텍스트, 스크린샷, 폰트, 번호이(가) 표시된 사진&#10;&#10;AI 생성 콘텐츠는 정확하지 않을 수 있습니다.">
+            <a:extLst>
+              <a:ext uri="{FF2B5EF4-FFF2-40B4-BE49-F238E27FC236}">
+                <a16:creationId xmlns:a16="http://schemas.microsoft.com/office/drawing/2014/main" id="{34CF9855-DA62-5946-6818-80AC155A6F94}"/>
+              </a:ext>
+            </a:extLst>
+          </p:cNvPr>
+          <p:cNvPicPr>
+            <a:picLocks noChangeAspect="1"/>
+          </p:cNvPicPr>
+          <p:nvPr/>
+        </p:nvPicPr>
+        <p:blipFill>
+          <a:blip r:embed="rId3"/>
+          <a:stretch>
+            <a:fillRect/>
+          </a:stretch>
+        </p:blipFill>
+        <p:spPr>
+          <a:xfrm>
+            <a:off x="5966766" y="957900"/>
+            <a:ext cx="2763265" cy="5488620"/>
+          </a:xfrm>
+          <a:prstGeom prst="rect">
+            <a:avLst/>
+          </a:prstGeom>
+        </p:spPr>
+      </p:pic>
+      <p:pic>
+        <p:nvPicPr>
+          <p:cNvPr id="10" name="그림 9" descr="텍스트, 스크린샷, 폰트, 번호이(가) 표시된 사진&#10;&#10;AI 생성 콘텐츠는 정확하지 않을 수 있습니다.">
+            <a:extLst>
+              <a:ext uri="{FF2B5EF4-FFF2-40B4-BE49-F238E27FC236}">
+                <a16:creationId xmlns:a16="http://schemas.microsoft.com/office/drawing/2014/main" id="{FE8C23A4-2020-EE6E-9A23-064DBA37E7AF}"/>
+              </a:ext>
+            </a:extLst>
+          </p:cNvPr>
+          <p:cNvPicPr>
+            <a:picLocks noChangeAspect="1"/>
+          </p:cNvPicPr>
+          <p:nvPr/>
+        </p:nvPicPr>
+        <p:blipFill>
+          <a:blip r:embed="rId4"/>
+          <a:stretch>
+            <a:fillRect/>
+          </a:stretch>
+        </p:blipFill>
+        <p:spPr>
+          <a:xfrm>
+            <a:off x="9093302" y="895451"/>
+            <a:ext cx="2763265" cy="5488622"/>
+          </a:xfrm>
+          <a:prstGeom prst="rect">
+            <a:avLst/>
+          </a:prstGeom>
+        </p:spPr>
+      </p:pic>
+    </p:spTree>
+  </p:cSld>
+  <p:clrMapOvr>
+    <a:masterClrMapping/>
+  </p:clrMapOvr>
+</p:sld>
+</file>
+
+<file path=ppt/slides/slide6.xml><?xml version="1.0" encoding="utf-8"?>
+<p:sld xmlns:a="http://schemas.openxmlformats.org/drawingml/2006/main" xmlns:r="http://schemas.openxmlformats.org/officeDocument/2006/relationships" xmlns:p="http://schemas.openxmlformats.org/presentationml/2006/main">
+  <p:cSld>
+    <p:spTree>
+      <p:nvGrpSpPr>
+        <p:cNvPr id="1" name=""/>
+        <p:cNvGrpSpPr/>
+        <p:nvPr/>
+      </p:nvGrpSpPr>
+      <p:grpSpPr>
+        <a:xfrm>
+          <a:off x="0" y="0"/>
+          <a:ext cx="0" cy="0"/>
+          <a:chOff x="0" y="0"/>
+          <a:chExt cx="0" cy="0"/>
+        </a:xfrm>
+      </p:grpSpPr>
+      <p:sp>
+        <p:nvSpPr>
+          <p:cNvPr id="2" name="Rectangle 1"/>
+          <p:cNvSpPr/>
+          <p:nvPr/>
+        </p:nvSpPr>
+        <p:spPr>
+          <a:xfrm>
+            <a:off x="0" y="0"/>
+            <a:ext cx="12191695" cy="6858000"/>
+          </a:xfrm>
+          <a:prstGeom prst="rect">
+            <a:avLst/>
+          </a:prstGeom>
+          <a:solidFill>
+            <a:srgbClr val="F3F4F3"/>
+          </a:solidFill>
+          <a:ln>
+            <a:noFill/>
+          </a:ln>
+          <a:effectLst/>
+        </p:spPr>
+        <p:style>
+          <a:lnRef idx="1">
+            <a:schemeClr val="accent1"/>
+          </a:lnRef>
+          <a:fillRef idx="3">
+            <a:schemeClr val="accent1"/>
+          </a:fillRef>
+          <a:effectRef idx="2">
+            <a:schemeClr val="accent1"/>
+          </a:effectRef>
+          <a:fontRef idx="minor">
+            <a:schemeClr val="lt1"/>
+          </a:fontRef>
+        </p:style>
+        <p:txBody>
+          <a:bodyPr rtlCol="0" anchor="ctr"/>
+          <a:lstStyle/>
+          <a:p>
+            <a:pPr algn="ctr"/>
+            <a:endParaRPr/>
+          </a:p>
+        </p:txBody>
+      </p:sp>
+      <p:sp>
+        <p:nvSpPr>
+          <p:cNvPr id="3" name="Rectangle 2"/>
+          <p:cNvSpPr/>
+          <p:nvPr/>
+        </p:nvSpPr>
+        <p:spPr>
+          <a:xfrm>
+            <a:off x="914400" y="2743200"/>
+            <a:ext cx="164592" cy="1280160"/>
+          </a:xfrm>
+          <a:prstGeom prst="rect">
+            <a:avLst/>
+          </a:prstGeom>
+          <a:solidFill>
+            <a:srgbClr val="2D6A4F"/>
+          </a:solidFill>
+          <a:ln>
+            <a:noFill/>
+          </a:ln>
+          <a:effectLst/>
+        </p:spPr>
+        <p:style>
+          <a:lnRef idx="1">
+            <a:schemeClr val="accent1"/>
+          </a:lnRef>
+          <a:fillRef idx="3">
+            <a:schemeClr val="accent1"/>
+          </a:fillRef>
+          <a:effectRef idx="2">
+            <a:schemeClr val="accent1"/>
+          </a:effectRef>
+          <a:fontRef idx="minor">
+            <a:schemeClr val="lt1"/>
+          </a:fontRef>
+        </p:style>
+        <p:txBody>
+          <a:bodyPr rtlCol="0" anchor="ctr"/>
+          <a:lstStyle/>
+          <a:p>
+            <a:pPr algn="ctr"/>
+            <a:endParaRPr/>
+          </a:p>
+        </p:txBody>
+      </p:sp>
+      <p:sp>
+        <p:nvSpPr>
+          <p:cNvPr id="4" name="TextBox 3"/>
+          <p:cNvSpPr txBox="1"/>
+          <p:nvPr/>
+        </p:nvSpPr>
+        <p:spPr>
+          <a:xfrm>
+            <a:off x="1280160" y="2743200"/>
+            <a:ext cx="9601200" cy="1280160"/>
+          </a:xfrm>
+          <a:prstGeom prst="rect">
+            <a:avLst/>
+          </a:prstGeom>
+          <a:noFill/>
+        </p:spPr>
+        <p:txBody>
+          <a:bodyPr wrap="square" lIns="45720" tIns="27432" rIns="45720" bIns="27432" anchor="ctr">
+            <a:spAutoFit/>
+          </a:bodyPr>
+          <a:lstStyle/>
+          <a:p>
+            <a:pPr algn="l">
+              <a:spcAft>
+                <a:spcPts val="600"/>
+              </a:spcAft>
+            </a:pPr>
+            <a:r>
+              <a:rPr sz="3400" b="1">
+                <a:solidFill>
+                  <a:srgbClr val="1C1C1A"/>
+                </a:solidFill>
+                <a:latin typeface="PingFang SC"/>
+                <a:ea typeface="PingFang SC"/>
+                <a:cs typeface="PingFang SC"/>
+              </a:rPr>
+              <a:t>传道员 — 4 个标签</a:t>
+            </a:r>
+          </a:p>
+        </p:txBody>
+      </p:sp>
+    </p:spTree>
+  </p:cSld>
+  <p:clrMapOvr>
+    <a:masterClrMapping/>
+  </p:clrMapOvr>
+</p:sld>
+</file>
+
+<file path=ppt/slides/slide7.xml><?xml version="1.0" encoding="utf-8"?>
+<p:sld xmlns:a="http://schemas.openxmlformats.org/drawingml/2006/main" xmlns:r="http://schemas.openxmlformats.org/officeDocument/2006/relationships" xmlns:p="http://schemas.openxmlformats.org/presentationml/2006/main">
+  <p:cSld>
+    <p:spTree>
+      <p:nvGrpSpPr>
+        <p:cNvPr id="1" name=""/>
+        <p:cNvGrpSpPr/>
+        <p:nvPr/>
+      </p:nvGrpSpPr>
+      <p:grpSpPr>
+        <a:xfrm>
+          <a:off x="0" y="0"/>
+          <a:ext cx="0" cy="0"/>
+          <a:chOff x="0" y="0"/>
+          <a:chExt cx="0" cy="0"/>
+        </a:xfrm>
+      </p:grpSpPr>
+      <p:sp>
+        <p:nvSpPr>
+          <p:cNvPr id="2" name="Rectangle 1"/>
+          <p:cNvSpPr/>
+          <p:nvPr/>
+        </p:nvSpPr>
+        <p:spPr>
+          <a:xfrm>
+            <a:off x="0" y="0"/>
+            <a:ext cx="12191695" cy="6858000"/>
+          </a:xfrm>
+          <a:prstGeom prst="rect">
+            <a:avLst/>
+          </a:prstGeom>
+          <a:solidFill>
+            <a:srgbClr val="FFFFFF"/>
+          </a:solidFill>
+          <a:ln>
+            <a:noFill/>
+          </a:ln>
+          <a:effectLst/>
+        </p:spPr>
+        <p:style>
+          <a:lnRef idx="1">
+            <a:schemeClr val="accent1"/>
+          </a:lnRef>
+          <a:fillRef idx="3">
+            <a:schemeClr val="accent1"/>
+          </a:fillRef>
+          <a:effectRef idx="2">
+            <a:schemeClr val="accent1"/>
+          </a:effectRef>
+          <a:fontRef idx="minor">
+            <a:schemeClr val="lt1"/>
+          </a:fontRef>
+        </p:style>
+        <p:txBody>
+          <a:bodyPr rtlCol="0" anchor="ctr"/>
+          <a:lstStyle/>
+          <a:p>
+            <a:pPr algn="ctr"/>
+            <a:endParaRPr/>
+          </a:p>
+        </p:txBody>
+      </p:sp>
+      <p:sp>
+        <p:nvSpPr>
+          <p:cNvPr id="3" name="Rectangle 2"/>
+          <p:cNvSpPr/>
+          <p:nvPr/>
+        </p:nvSpPr>
+        <p:spPr>
+          <a:xfrm>
+            <a:off x="0" y="0"/>
+            <a:ext cx="201168" cy="1371600"/>
+          </a:xfrm>
+          <a:prstGeom prst="rect">
+            <a:avLst/>
+          </a:prstGeom>
+          <a:solidFill>
+            <a:srgbClr val="2D6A4F"/>
+          </a:solidFill>
+          <a:ln>
+            <a:noFill/>
+          </a:ln>
+          <a:effectLst/>
+        </p:spPr>
+        <p:style>
+          <a:lnRef idx="1">
+            <a:schemeClr val="accent1"/>
+          </a:lnRef>
+          <a:fillRef idx="3">
+            <a:schemeClr val="accent1"/>
+          </a:fillRef>
+          <a:effectRef idx="2">
+            <a:schemeClr val="accent1"/>
+          </a:effectRef>
+          <a:fontRef idx="minor">
+            <a:schemeClr val="lt1"/>
+          </a:fontRef>
+        </p:style>
+        <p:txBody>
+          <a:bodyPr rtlCol="0" anchor="ctr"/>
+          <a:lstStyle/>
+          <a:p>
+            <a:pPr algn="ctr"/>
+            <a:endParaRPr/>
+          </a:p>
+        </p:txBody>
+      </p:sp>
+      <p:sp>
+        <p:nvSpPr>
+          <p:cNvPr id="4" name="TextBox 3"/>
+          <p:cNvSpPr txBox="1"/>
+          <p:nvPr/>
+        </p:nvSpPr>
+        <p:spPr>
+          <a:xfrm>
+            <a:off x="548640" y="411480"/>
+            <a:ext cx="7315200" cy="914400"/>
+          </a:xfrm>
+          <a:prstGeom prst="rect">
+            <a:avLst/>
+          </a:prstGeom>
+          <a:noFill/>
+        </p:spPr>
+        <p:txBody>
+          <a:bodyPr wrap="square" lIns="45720" tIns="27432" rIns="45720" bIns="27432" anchor="t">
+            <a:spAutoFit/>
+          </a:bodyPr>
+          <a:lstStyle/>
+          <a:p>
+            <a:pPr algn="l">
+              <a:spcAft>
+                <a:spcPts val="600"/>
+              </a:spcAft>
+            </a:pPr>
+            <a:r>
+              <a:rPr sz="3000" b="1">
+                <a:solidFill>
+                  <a:srgbClr val="1C1C1A"/>
+                </a:solidFill>
+                <a:latin typeface="PingFang SC"/>
+                <a:ea typeface="PingFang SC"/>
+                <a:cs typeface="PingFang SC"/>
+              </a:rPr>
+              <a:t>【首页】</a:t>
+            </a:r>
+          </a:p>
+        </p:txBody>
+      </p:sp>
+      <p:sp>
+        <p:nvSpPr>
+          <p:cNvPr id="5" name="TextBox 4"/>
+          <p:cNvSpPr txBox="1"/>
+          <p:nvPr/>
+        </p:nvSpPr>
+        <p:spPr>
+          <a:xfrm>
+            <a:off x="588758" y="1645920"/>
+            <a:ext cx="6766560" cy="1609671"/>
+          </a:xfrm>
+          <a:prstGeom prst="rect">
+            <a:avLst/>
+          </a:prstGeom>
+          <a:noFill/>
+        </p:spPr>
+        <p:txBody>
+          <a:bodyPr wrap="square" lIns="45720" tIns="27432" rIns="45720" bIns="27432" anchor="t">
+            <a:spAutoFit/>
+          </a:bodyPr>
+          <a:lstStyle/>
+          <a:p>
+            <a:pPr algn="l">
+              <a:spcAft>
+                <a:spcPts val="1000"/>
+              </a:spcAft>
+            </a:pPr>
+            <a:r>
+              <a:rPr sz="1900" b="0" dirty="0">
+                <a:solidFill>
+                  <a:srgbClr val="1C1C1A"/>
+                </a:solidFill>
+                <a:latin typeface="PingFang SC"/>
+                <a:ea typeface="PingFang SC"/>
+                <a:cs typeface="PingFang SC"/>
+              </a:rPr>
+              <a:t>①  </a:t>
+            </a:r>
+            <a:r>
+              <a:rPr sz="1900" b="0" dirty="0" err="1">
+                <a:solidFill>
+                  <a:srgbClr val="1C1C1A"/>
+                </a:solidFill>
+                <a:latin typeface="PingFang SC"/>
+                <a:ea typeface="PingFang SC"/>
+                <a:cs typeface="PingFang SC"/>
+              </a:rPr>
+              <a:t>今天</a:t>
+            </a:r>
+            <a:r>
+              <a:rPr sz="1900" b="0" dirty="0">
+                <a:solidFill>
+                  <a:srgbClr val="1C1C1A"/>
+                </a:solidFill>
+                <a:latin typeface="PingFang SC"/>
+                <a:ea typeface="PingFang SC"/>
+                <a:cs typeface="PingFang SC"/>
+              </a:rPr>
+              <a:t> / </a:t>
+            </a:r>
+            <a:r>
+              <a:rPr sz="1900" b="0" dirty="0" err="1">
+                <a:solidFill>
+                  <a:srgbClr val="1C1C1A"/>
+                </a:solidFill>
+                <a:latin typeface="PingFang SC"/>
+                <a:ea typeface="PingFang SC"/>
+                <a:cs typeface="PingFang SC"/>
+              </a:rPr>
+              <a:t>近期日程</a:t>
+            </a:r>
+            <a:endParaRPr sz="1900" b="0" dirty="0">
+              <a:solidFill>
+                <a:srgbClr val="1C1C1A"/>
+              </a:solidFill>
+              <a:latin typeface="PingFang SC"/>
+              <a:ea typeface="PingFang SC"/>
+              <a:cs typeface="PingFang SC"/>
+            </a:endParaRPr>
+          </a:p>
+          <a:p>
+            <a:pPr algn="l">
+              <a:spcAft>
+                <a:spcPts val="1000"/>
+              </a:spcAft>
+            </a:pPr>
+            <a:r>
+              <a:rPr sz="1900" b="0" dirty="0">
+                <a:solidFill>
+                  <a:srgbClr val="1C1C1A"/>
+                </a:solidFill>
+                <a:latin typeface="PingFang SC"/>
+                <a:ea typeface="PingFang SC"/>
+                <a:cs typeface="PingFang SC"/>
+              </a:rPr>
+              <a:t>②  </a:t>
+            </a:r>
+            <a:r>
+              <a:rPr sz="1900" b="0" dirty="0" err="1">
+                <a:solidFill>
+                  <a:srgbClr val="1C1C1A"/>
+                </a:solidFill>
+                <a:latin typeface="PingFang SC"/>
+                <a:ea typeface="PingFang SC"/>
+                <a:cs typeface="PingFang SC"/>
+              </a:rPr>
+              <a:t>特别传道横幅（进行中时</a:t>
+            </a:r>
+            <a:r>
+              <a:rPr sz="1900" b="0" dirty="0">
+                <a:solidFill>
+                  <a:srgbClr val="1C1C1A"/>
+                </a:solidFill>
+                <a:latin typeface="PingFang SC"/>
+                <a:ea typeface="PingFang SC"/>
+                <a:cs typeface="PingFang SC"/>
+              </a:rPr>
+              <a:t>）</a:t>
+            </a:r>
+          </a:p>
+          <a:p>
+            <a:pPr algn="l">
+              <a:spcAft>
+                <a:spcPts val="1000"/>
+              </a:spcAft>
+            </a:pPr>
+            <a:r>
+              <a:rPr sz="1900" b="0" dirty="0">
+                <a:solidFill>
+                  <a:srgbClr val="1C1C1A"/>
+                </a:solidFill>
+                <a:latin typeface="PingFang SC"/>
+                <a:ea typeface="PingFang SC"/>
+                <a:cs typeface="PingFang SC"/>
+              </a:rPr>
+              <a:t>③  </a:t>
+            </a:r>
+            <a:r>
+              <a:rPr sz="1900" b="0" dirty="0" err="1">
+                <a:solidFill>
+                  <a:srgbClr val="1C1C1A"/>
+                </a:solidFill>
+                <a:latin typeface="PingFang SC"/>
+                <a:ea typeface="PingFang SC"/>
+                <a:cs typeface="PingFang SC"/>
+              </a:rPr>
+              <a:t>对话建议</a:t>
+            </a:r>
+            <a:endParaRPr lang="ko-KR" altLang="en-US" sz="1900" b="0" dirty="0">
+              <a:solidFill>
+                <a:srgbClr val="1C1C1A"/>
+              </a:solidFill>
+              <a:latin typeface="PingFang SC"/>
+              <a:ea typeface="PingFang SC"/>
+              <a:cs typeface="PingFang SC"/>
+            </a:endParaRPr>
+          </a:p>
+          <a:p>
+            <a:pPr algn="l">
+              <a:spcAft>
+                <a:spcPts val="1000"/>
+              </a:spcAft>
+            </a:pPr>
+            <a:r>
+              <a:rPr lang="en-US" altLang="ko-KR" sz="1900" b="0" dirty="0">
+                <a:solidFill>
+                  <a:srgbClr val="1C1C1A"/>
+                </a:solidFill>
+                <a:latin typeface="PingFang SC"/>
+                <a:ea typeface="PingFang SC"/>
+                <a:cs typeface="PingFang SC"/>
+              </a:rPr>
+              <a:t>④  </a:t>
+            </a:r>
+            <a:r>
+              <a:rPr lang="ko-KR" altLang="en-US" sz="1900" b="0" dirty="0" err="1">
+                <a:solidFill>
+                  <a:srgbClr val="1C1C1A"/>
+                </a:solidFill>
+                <a:latin typeface="PingFang SC"/>
+                <a:ea typeface="PingFang SC"/>
+                <a:cs typeface="PingFang SC"/>
+              </a:rPr>
+              <a:t>顶部</a:t>
+            </a:r>
+            <a:r>
+              <a:rPr lang="ko-KR" altLang="en-US" sz="1900" b="0" dirty="0">
+                <a:solidFill>
+                  <a:srgbClr val="1C1C1A"/>
+                </a:solidFill>
+                <a:latin typeface="PingFang SC"/>
+                <a:ea typeface="PingFang SC"/>
+                <a:cs typeface="PingFang SC"/>
+              </a:rPr>
+              <a:t> </a:t>
+            </a:r>
+            <a:r>
+              <a:rPr lang="ko-Kore-KR" altLang="en-US" sz="1900" b="0" dirty="0">
+                <a:solidFill>
+                  <a:srgbClr val="1C1C1A"/>
+                </a:solidFill>
+                <a:latin typeface="PingFang SC"/>
+                <a:ea typeface="PingFang SC"/>
+                <a:cs typeface="PingFang SC"/>
+              </a:rPr>
+              <a:t>🔔 </a:t>
+            </a:r>
+            <a:r>
+              <a:rPr lang="ko-KR" altLang="en-US" sz="1900" b="0" dirty="0" err="1">
+                <a:solidFill>
+                  <a:srgbClr val="1C1C1A"/>
+                </a:solidFill>
+                <a:latin typeface="PingFang SC"/>
+                <a:ea typeface="PingFang SC"/>
+                <a:cs typeface="PingFang SC"/>
+              </a:rPr>
+              <a:t>通知</a:t>
+            </a:r>
+            <a:r>
+              <a:rPr lang="ko-KR" altLang="en-US" sz="1900" b="0" dirty="0">
+                <a:solidFill>
+                  <a:srgbClr val="1C1C1A"/>
+                </a:solidFill>
+                <a:latin typeface="PingFang SC"/>
+                <a:ea typeface="PingFang SC"/>
+                <a:cs typeface="PingFang SC"/>
+              </a:rPr>
+              <a:t> </a:t>
+            </a:r>
+            <a:r>
+              <a:rPr lang="en-US" altLang="ko-KR" sz="1900" b="0" dirty="0">
+                <a:solidFill>
+                  <a:srgbClr val="1C1C1A"/>
+                </a:solidFill>
+                <a:latin typeface="PingFang SC"/>
+                <a:ea typeface="PingFang SC"/>
+                <a:cs typeface="PingFang SC"/>
+              </a:rPr>
+              <a:t>· </a:t>
+            </a:r>
+            <a:r>
+              <a:rPr lang="ko-Kore-KR" altLang="en-US" sz="1900" b="0" dirty="0">
+                <a:solidFill>
+                  <a:srgbClr val="1C1C1A"/>
+                </a:solidFill>
+                <a:latin typeface="PingFang SC"/>
+                <a:ea typeface="PingFang SC"/>
+                <a:cs typeface="PingFang SC"/>
+              </a:rPr>
+              <a:t>💬 </a:t>
+            </a:r>
+            <a:r>
+              <a:rPr lang="ko-KR" altLang="en-US" sz="1900" b="0" dirty="0" err="1">
+                <a:solidFill>
+                  <a:srgbClr val="1C1C1A"/>
+                </a:solidFill>
+                <a:latin typeface="PingFang SC"/>
+                <a:ea typeface="PingFang SC"/>
+                <a:cs typeface="PingFang SC"/>
+              </a:rPr>
+              <a:t>聊天</a:t>
+            </a:r>
+            <a:endParaRPr lang="ko-KR" altLang="en-US" sz="1900" b="0" dirty="0">
+              <a:solidFill>
+                <a:srgbClr val="1C1C1A"/>
+              </a:solidFill>
+              <a:latin typeface="PingFang SC"/>
+              <a:ea typeface="PingFang SC"/>
+              <a:cs typeface="PingFang SC"/>
+            </a:endParaRPr>
           </a:p>
         </p:txBody>
       </p:sp>
@@ -7630,6 +9221,7 @@
           <a:lstStyle/>
           <a:p>
             <a:pPr algn="ctr"/>
+            <a:endParaRPr/>
           </a:p>
         </p:txBody>
       </p:sp>
@@ -7650,7 +9242,7 @@
           <a:noFill/>
         </p:spPr>
         <p:txBody>
-          <a:bodyPr wrap="square" anchor="ctr" lIns="45720" rIns="45720" tIns="27432" bIns="27432">
+          <a:bodyPr wrap="square" lIns="45720" tIns="27432" rIns="45720" bIns="27432" anchor="ctr">
             <a:spAutoFit/>
           </a:bodyPr>
           <a:lstStyle/>
@@ -7691,7 +9283,7 @@
           <a:noFill/>
         </p:spPr>
         <p:txBody>
-          <a:bodyPr wrap="square" anchor="ctr" lIns="45720" rIns="45720" tIns="27432" bIns="27432">
+          <a:bodyPr wrap="square" lIns="45720" tIns="27432" rIns="45720" bIns="27432" anchor="ctr">
             <a:spAutoFit/>
           </a:bodyPr>
           <a:lstStyle/>
@@ -7710,11 +9302,41 @@
                 <a:ea typeface="PingFang SC"/>
                 <a:cs typeface="PingFang SC"/>
               </a:rPr>
-              <a:t>底部标签栏</a:t>
-            </a:r>
-          </a:p>
-        </p:txBody>
-      </p:sp>
+              <a:t>首页</a:t>
+            </a:r>
+          </a:p>
+        </p:txBody>
+      </p:sp>
+      <p:pic>
+        <p:nvPicPr>
+          <p:cNvPr id="9" name="그림 8" descr="텍스트, 스크린샷, 폰트, 번호이(가) 표시된 사진&#10;&#10;AI 생성 콘텐츠는 정확하지 않을 수 있습니다.">
+            <a:extLst>
+              <a:ext uri="{FF2B5EF4-FFF2-40B4-BE49-F238E27FC236}">
+                <a16:creationId xmlns:a16="http://schemas.microsoft.com/office/drawing/2014/main" id="{DF89C5B8-185B-BDF6-C14C-3B0947A8C27A}"/>
+              </a:ext>
+            </a:extLst>
+          </p:cNvPr>
+          <p:cNvPicPr>
+            <a:picLocks noChangeAspect="1"/>
+          </p:cNvPicPr>
+          <p:nvPr/>
+        </p:nvPicPr>
+        <p:blipFill>
+          <a:blip r:embed="rId2"/>
+          <a:stretch>
+            <a:fillRect/>
+          </a:stretch>
+        </p:blipFill>
+        <p:spPr>
+          <a:xfrm>
+            <a:off x="7944075" y="0"/>
+            <a:ext cx="3577364" cy="6858000"/>
+          </a:xfrm>
+          <a:prstGeom prst="rect">
+            <a:avLst/>
+          </a:prstGeom>
+        </p:spPr>
+      </p:pic>
     </p:spTree>
   </p:cSld>
   <p:clrMapOvr>
@@ -7723,8 +9345,8 @@
 </p:sld>
 </file>
 
-<file path=ppt/slides/slide6.xml><?xml version="1.0" encoding="utf-8"?>
-<p:sld xmlns:a="http://schemas.openxmlformats.org/drawingml/2006/main" xmlns:p="http://schemas.openxmlformats.org/presentationml/2006/main" xmlns:r="http://schemas.openxmlformats.org/officeDocument/2006/relationships">
+<file path=ppt/slides/slide8.xml><?xml version="1.0" encoding="utf-8"?>
+<p:sld xmlns:a="http://schemas.openxmlformats.org/drawingml/2006/main" xmlns:r="http://schemas.openxmlformats.org/officeDocument/2006/relationships" xmlns:p="http://schemas.openxmlformats.org/presentationml/2006/main">
   <p:cSld>
     <p:spTree>
       <p:nvGrpSpPr>
@@ -7732,7 +9354,14 @@
         <p:cNvGrpSpPr/>
         <p:nvPr/>
       </p:nvGrpSpPr>
-      <p:grpSpPr/>
+      <p:grpSpPr>
+        <a:xfrm>
+          <a:off x="0" y="0"/>
+          <a:ext cx="0" cy="0"/>
+          <a:chOff x="0" y="0"/>
+          <a:chExt cx="0" cy="0"/>
+        </a:xfrm>
+      </p:grpSpPr>
       <p:sp>
         <p:nvSpPr>
           <p:cNvPr id="2" name="Rectangle 1"/>
@@ -7748,7 +9377,7 @@
             <a:avLst/>
           </a:prstGeom>
           <a:solidFill>
-            <a:srgbClr val="F3F4F3"/>
+            <a:srgbClr val="FFFFFF"/>
           </a:solidFill>
           <a:ln>
             <a:noFill/>
@@ -7774,6 +9403,7 @@
           <a:lstStyle/>
           <a:p>
             <a:pPr algn="ctr"/>
+            <a:endParaRPr/>
           </a:p>
         </p:txBody>
       </p:sp>
@@ -7785,8 +9415,8 @@
         </p:nvSpPr>
         <p:spPr>
           <a:xfrm>
-            <a:off x="914400" y="2743200"/>
-            <a:ext cx="164592" cy="1280160"/>
+            <a:off x="0" y="0"/>
+            <a:ext cx="201168" cy="1371600"/>
           </a:xfrm>
           <a:prstGeom prst="rect">
             <a:avLst/>
@@ -7818,6 +9448,7 @@
           <a:lstStyle/>
           <a:p>
             <a:pPr algn="ctr"/>
+            <a:endParaRPr/>
           </a:p>
         </p:txBody>
       </p:sp>
@@ -7829,8 +9460,8 @@
         </p:nvSpPr>
         <p:spPr>
           <a:xfrm>
-            <a:off x="1280160" y="2743200"/>
-            <a:ext cx="9601200" cy="1280160"/>
+            <a:off x="548640" y="411480"/>
+            <a:ext cx="7315200" cy="914400"/>
           </a:xfrm>
           <a:prstGeom prst="rect">
             <a:avLst/>
@@ -7838,7 +9469,7 @@
           <a:noFill/>
         </p:spPr>
         <p:txBody>
-          <a:bodyPr wrap="square" anchor="ctr" lIns="45720" rIns="45720" tIns="27432" bIns="27432">
+          <a:bodyPr wrap="square" lIns="45720" tIns="27432" rIns="45720" bIns="27432" anchor="t">
             <a:spAutoFit/>
           </a:bodyPr>
           <a:lstStyle/>
@@ -7849,7 +9480,7 @@
               </a:spcAft>
             </a:pPr>
             <a:r>
-              <a:rPr sz="3400" b="1">
+              <a:rPr sz="3000" b="1">
                 <a:solidFill>
                   <a:srgbClr val="1C1C1A"/>
                 </a:solidFill>
@@ -7857,127 +9488,21 @@
                 <a:ea typeface="PingFang SC"/>
                 <a:cs typeface="PingFang SC"/>
               </a:rPr>
-              <a:t>传道员 — 4 个标签</a:t>
-            </a:r>
-          </a:p>
-        </p:txBody>
-      </p:sp>
-    </p:spTree>
-  </p:cSld>
-  <p:clrMapOvr>
-    <a:masterClrMapping/>
-  </p:clrMapOvr>
-</p:sld>
-</file>
-
-<file path=ppt/slides/slide7.xml><?xml version="1.0" encoding="utf-8"?>
-<p:sld xmlns:a="http://schemas.openxmlformats.org/drawingml/2006/main" xmlns:p="http://schemas.openxmlformats.org/presentationml/2006/main" xmlns:r="http://schemas.openxmlformats.org/officeDocument/2006/relationships">
-  <p:cSld>
-    <p:spTree>
-      <p:nvGrpSpPr>
-        <p:cNvPr id="1" name=""/>
-        <p:cNvGrpSpPr/>
-        <p:nvPr/>
-      </p:nvGrpSpPr>
-      <p:grpSpPr/>
-      <p:sp>
-        <p:nvSpPr>
-          <p:cNvPr id="2" name="Rectangle 1"/>
-          <p:cNvSpPr/>
-          <p:nvPr/>
-        </p:nvSpPr>
-        <p:spPr>
-          <a:xfrm>
-            <a:off x="0" y="0"/>
-            <a:ext cx="12191695" cy="6858000"/>
-          </a:xfrm>
-          <a:prstGeom prst="rect">
-            <a:avLst/>
-          </a:prstGeom>
-          <a:solidFill>
-            <a:srgbClr val="FFFFFF"/>
-          </a:solidFill>
-          <a:ln>
-            <a:noFill/>
-          </a:ln>
-          <a:effectLst/>
-        </p:spPr>
-        <p:style>
-          <a:lnRef idx="1">
-            <a:schemeClr val="accent1"/>
-          </a:lnRef>
-          <a:fillRef idx="3">
-            <a:schemeClr val="accent1"/>
-          </a:fillRef>
-          <a:effectRef idx="2">
-            <a:schemeClr val="accent1"/>
-          </a:effectRef>
-          <a:fontRef idx="minor">
-            <a:schemeClr val="lt1"/>
-          </a:fontRef>
-        </p:style>
-        <p:txBody>
-          <a:bodyPr rtlCol="0" anchor="ctr"/>
-          <a:lstStyle/>
-          <a:p>
-            <a:pPr algn="ctr"/>
-          </a:p>
-        </p:txBody>
-      </p:sp>
-      <p:sp>
-        <p:nvSpPr>
-          <p:cNvPr id="3" name="Rectangle 2"/>
-          <p:cNvSpPr/>
-          <p:nvPr/>
-        </p:nvSpPr>
-        <p:spPr>
-          <a:xfrm>
-            <a:off x="0" y="0"/>
-            <a:ext cx="201168" cy="1371600"/>
-          </a:xfrm>
-          <a:prstGeom prst="rect">
-            <a:avLst/>
-          </a:prstGeom>
-          <a:solidFill>
-            <a:srgbClr val="2D6A4F"/>
-          </a:solidFill>
-          <a:ln>
-            <a:noFill/>
-          </a:ln>
-          <a:effectLst/>
-        </p:spPr>
-        <p:style>
-          <a:lnRef idx="1">
-            <a:schemeClr val="accent1"/>
-          </a:lnRef>
-          <a:fillRef idx="3">
-            <a:schemeClr val="accent1"/>
-          </a:fillRef>
-          <a:effectRef idx="2">
-            <a:schemeClr val="accent1"/>
-          </a:effectRef>
-          <a:fontRef idx="minor">
-            <a:schemeClr val="lt1"/>
-          </a:fontRef>
-        </p:style>
-        <p:txBody>
-          <a:bodyPr rtlCol="0" anchor="ctr"/>
-          <a:lstStyle/>
-          <a:p>
-            <a:pPr algn="ctr"/>
-          </a:p>
-        </p:txBody>
-      </p:sp>
-      <p:sp>
-        <p:nvSpPr>
-          <p:cNvPr id="4" name="TextBox 3"/>
+              <a:t>【日历】 — 申请参与</a:t>
+            </a:r>
+          </a:p>
+        </p:txBody>
+      </p:sp>
+      <p:sp>
+        <p:nvSpPr>
+          <p:cNvPr id="5" name="TextBox 4"/>
           <p:cNvSpPr txBox="1"/>
           <p:nvPr/>
         </p:nvSpPr>
         <p:spPr>
           <a:xfrm>
-            <a:off x="548640" y="411480"/>
-            <a:ext cx="7315200" cy="914400"/>
+            <a:off x="594360" y="1645920"/>
+            <a:ext cx="6766560" cy="4754880"/>
           </a:xfrm>
           <a:prstGeom prst="rect">
             <a:avLst/>
@@ -7985,10 +9510,64 @@
           <a:noFill/>
         </p:spPr>
         <p:txBody>
-          <a:bodyPr wrap="square" anchor="t" lIns="45720" rIns="45720" tIns="27432" bIns="27432">
+          <a:bodyPr wrap="square" lIns="45720" tIns="27432" rIns="45720" bIns="27432" anchor="t">
             <a:spAutoFit/>
           </a:bodyPr>
           <a:lstStyle/>
+          <a:p>
+            <a:pPr algn="l">
+              <a:spcAft>
+                <a:spcPts val="1000"/>
+              </a:spcAft>
+            </a:pPr>
+            <a:r>
+              <a:rPr sz="1900" b="0">
+                <a:solidFill>
+                  <a:srgbClr val="1C1C1A"/>
+                </a:solidFill>
+                <a:latin typeface="PingFang SC"/>
+                <a:ea typeface="PingFang SC"/>
+                <a:cs typeface="PingFang SC"/>
+              </a:rPr>
+              <a:t>①  点日期</a:t>
+            </a:r>
+          </a:p>
+          <a:p>
+            <a:pPr algn="l">
+              <a:spcAft>
+                <a:spcPts val="1000"/>
+              </a:spcAft>
+            </a:pPr>
+            <a:r>
+              <a:rPr sz="1900" b="0">
+                <a:solidFill>
+                  <a:srgbClr val="1C1C1A"/>
+                </a:solidFill>
+                <a:latin typeface="PingFang SC"/>
+                <a:ea typeface="PingFang SC"/>
+                <a:cs typeface="PingFang SC"/>
+              </a:rPr>
+              <a:t>②  点当天日程</a:t>
+            </a:r>
+          </a:p>
+          <a:p>
+            <a:pPr algn="l">
+              <a:spcAft>
+                <a:spcPts val="1000"/>
+              </a:spcAft>
+            </a:pPr>
+            <a:r>
+              <a:rPr sz="1900" b="0">
+                <a:solidFill>
+                  <a:srgbClr val="1C1C1A"/>
+                </a:solidFill>
+                <a:latin typeface="PingFang SC"/>
+                <a:ea typeface="PingFang SC"/>
+                <a:cs typeface="PingFang SC"/>
+              </a:rPr>
+              <a:t>③  “申请参与”（取消在同一处）</a:t>
+            </a:r>
+          </a:p>
           <a:p>
             <a:pPr algn="l">
               <a:spcAft>
@@ -7996,119 +9575,6 @@
               </a:spcAft>
             </a:pPr>
             <a:r>
-              <a:rPr sz="3000" b="1">
-                <a:solidFill>
-                  <a:srgbClr val="1C1C1A"/>
-                </a:solidFill>
-                <a:latin typeface="PingFang SC"/>
-                <a:ea typeface="PingFang SC"/>
-                <a:cs typeface="PingFang SC"/>
-              </a:rPr>
-              <a:t>【首页】</a:t>
-            </a:r>
-          </a:p>
-        </p:txBody>
-      </p:sp>
-      <p:sp>
-        <p:nvSpPr>
-          <p:cNvPr id="5" name="TextBox 4"/>
-          <p:cNvSpPr txBox="1"/>
-          <p:nvPr/>
-        </p:nvSpPr>
-        <p:spPr>
-          <a:xfrm>
-            <a:off x="594360" y="1645920"/>
-            <a:ext cx="6766560" cy="4754880"/>
-          </a:xfrm>
-          <a:prstGeom prst="rect">
-            <a:avLst/>
-          </a:prstGeom>
-          <a:noFill/>
-        </p:spPr>
-        <p:txBody>
-          <a:bodyPr wrap="square" anchor="t" lIns="45720" rIns="45720" tIns="27432" bIns="27432">
-            <a:spAutoFit/>
-          </a:bodyPr>
-          <a:lstStyle/>
-          <a:p>
-            <a:pPr algn="l">
-              <a:spcAft>
-                <a:spcPts val="1000"/>
-              </a:spcAft>
-            </a:pPr>
-            <a:r>
-              <a:rPr sz="1900" b="0">
-                <a:solidFill>
-                  <a:srgbClr val="1C1C1A"/>
-                </a:solidFill>
-                <a:latin typeface="PingFang SC"/>
-                <a:ea typeface="PingFang SC"/>
-                <a:cs typeface="PingFang SC"/>
-              </a:rPr>
-              <a:t>①  今天 / 近期日程</a:t>
-            </a:r>
-          </a:p>
-          <a:p>
-            <a:pPr algn="l">
-              <a:spcAft>
-                <a:spcPts val="1000"/>
-              </a:spcAft>
-            </a:pPr>
-            <a:r>
-              <a:rPr sz="1900" b="0">
-                <a:solidFill>
-                  <a:srgbClr val="1C1C1A"/>
-                </a:solidFill>
-                <a:latin typeface="PingFang SC"/>
-                <a:ea typeface="PingFang SC"/>
-                <a:cs typeface="PingFang SC"/>
-              </a:rPr>
-              <a:t>②  特别传道横幅（进行中时）</a:t>
-            </a:r>
-          </a:p>
-          <a:p>
-            <a:pPr algn="l">
-              <a:spcAft>
-                <a:spcPts val="1000"/>
-              </a:spcAft>
-            </a:pPr>
-            <a:r>
-              <a:rPr sz="1900" b="0">
-                <a:solidFill>
-                  <a:srgbClr val="1C1C1A"/>
-                </a:solidFill>
-                <a:latin typeface="PingFang SC"/>
-                <a:ea typeface="PingFang SC"/>
-                <a:cs typeface="PingFang SC"/>
-              </a:rPr>
-              <a:t>③  对话建议（传道前参考问题·经文）</a:t>
-            </a:r>
-          </a:p>
-          <a:p>
-            <a:pPr algn="l">
-              <a:spcAft>
-                <a:spcPts val="1000"/>
-              </a:spcAft>
-            </a:pPr>
-            <a:r>
-              <a:rPr sz="1900" b="0">
-                <a:solidFill>
-                  <a:srgbClr val="1C1C1A"/>
-                </a:solidFill>
-                <a:latin typeface="PingFang SC"/>
-                <a:ea typeface="PingFang SC"/>
-                <a:cs typeface="PingFang SC"/>
-              </a:rPr>
-              <a:t>④  顶部 🔔 通知 · 💬 聊天</a:t>
-            </a:r>
-          </a:p>
-          <a:p>
-            <a:pPr algn="l">
-              <a:spcAft>
-                <a:spcPts val="600"/>
-              </a:spcAft>
-            </a:pPr>
-            <a:r>
               <a:rPr sz="1600" b="0">
                 <a:solidFill>
                   <a:srgbClr val="B45A09"/>
@@ -8117,7 +9583,7 @@
                 <a:ea typeface="PingFang SC"/>
                 <a:cs typeface="PingFang SC"/>
               </a:rPr>
-              <a:t>💡 “对话建议”出门传道前看很有用。</a:t>
+              <a:t>💡 日程里也能看聊天·参加者。</a:t>
             </a:r>
           </a:p>
         </p:txBody>
@@ -8165,6 +9631,7 @@
           <a:lstStyle/>
           <a:p>
             <a:pPr algn="ctr"/>
+            <a:endParaRPr/>
           </a:p>
         </p:txBody>
       </p:sp>
@@ -8185,7 +9652,7 @@
           <a:noFill/>
         </p:spPr>
         <p:txBody>
-          <a:bodyPr wrap="square" anchor="ctr" lIns="45720" rIns="45720" tIns="27432" bIns="27432">
+          <a:bodyPr wrap="square" lIns="45720" tIns="27432" rIns="45720" bIns="27432" anchor="ctr">
             <a:spAutoFit/>
           </a:bodyPr>
           <a:lstStyle/>
@@ -8226,7 +9693,7 @@
           <a:noFill/>
         </p:spPr>
         <p:txBody>
-          <a:bodyPr wrap="square" anchor="ctr" lIns="45720" rIns="45720" tIns="27432" bIns="27432">
+          <a:bodyPr wrap="square" lIns="45720" tIns="27432" rIns="45720" bIns="27432" anchor="ctr">
             <a:spAutoFit/>
           </a:bodyPr>
           <a:lstStyle/>
@@ -8245,7 +9712,7 @@
                 <a:ea typeface="PingFang SC"/>
                 <a:cs typeface="PingFang SC"/>
               </a:rPr>
-              <a:t>首页</a:t>
+              <a:t>日程详情 + 申请按钮</a:t>
             </a:r>
           </a:p>
         </p:txBody>
@@ -8258,8 +9725,8 @@
 </p:sld>
 </file>
 
-<file path=ppt/slides/slide8.xml><?xml version="1.0" encoding="utf-8"?>
-<p:sld xmlns:a="http://schemas.openxmlformats.org/drawingml/2006/main" xmlns:p="http://schemas.openxmlformats.org/presentationml/2006/main" xmlns:r="http://schemas.openxmlformats.org/officeDocument/2006/relationships">
+<file path=ppt/slides/slide9.xml><?xml version="1.0" encoding="utf-8"?>
+<p:sld xmlns:a="http://schemas.openxmlformats.org/drawingml/2006/main" xmlns:r="http://schemas.openxmlformats.org/officeDocument/2006/relationships" xmlns:p="http://schemas.openxmlformats.org/presentationml/2006/main">
   <p:cSld>
     <p:spTree>
       <p:nvGrpSpPr>
@@ -8267,7 +9734,14 @@
         <p:cNvGrpSpPr/>
         <p:nvPr/>
       </p:nvGrpSpPr>
-      <p:grpSpPr/>
+      <p:grpSpPr>
+        <a:xfrm>
+          <a:off x="0" y="0"/>
+          <a:ext cx="0" cy="0"/>
+          <a:chOff x="0" y="0"/>
+          <a:chExt cx="0" cy="0"/>
+        </a:xfrm>
+      </p:grpSpPr>
       <p:sp>
         <p:nvSpPr>
           <p:cNvPr id="2" name="Rectangle 1"/>
@@ -8309,6 +9783,7 @@
           <a:lstStyle/>
           <a:p>
             <a:pPr algn="ctr"/>
+            <a:endParaRPr/>
           </a:p>
         </p:txBody>
       </p:sp>
@@ -8353,6 +9828,7 @@
           <a:lstStyle/>
           <a:p>
             <a:pPr algn="ctr"/>
+            <a:endParaRPr/>
           </a:p>
         </p:txBody>
       </p:sp>
@@ -8373,7 +9849,7 @@
           <a:noFill/>
         </p:spPr>
         <p:txBody>
-          <a:bodyPr wrap="square" anchor="t" lIns="45720" rIns="45720" tIns="27432" bIns="27432">
+          <a:bodyPr wrap="square" lIns="45720" tIns="27432" rIns="45720" bIns="27432" anchor="t">
             <a:spAutoFit/>
           </a:bodyPr>
           <a:lstStyle/>
@@ -8392,7 +9868,7 @@
                 <a:ea typeface="PingFang SC"/>
                 <a:cs typeface="PingFang SC"/>
               </a:rPr>
-              <a:t>【日历】 — 申请参与</a:t>
+              <a:t>【我的传道】① 查看我的地区</a:t>
             </a:r>
           </a:p>
         </p:txBody>
@@ -8414,7 +9890,7 @@
           <a:noFill/>
         </p:spPr>
         <p:txBody>
-          <a:bodyPr wrap="square" anchor="t" lIns="45720" rIns="45720" tIns="27432" bIns="27432">
+          <a:bodyPr wrap="square" lIns="45720" tIns="27432" rIns="45720" bIns="27432" anchor="t">
             <a:spAutoFit/>
           </a:bodyPr>
           <a:lstStyle/>
@@ -8433,7 +9909,7 @@
                 <a:ea typeface="PingFang SC"/>
                 <a:cs typeface="PingFang SC"/>
               </a:rPr>
-              <a:t>①  点日期</a:t>
+              <a:t>①  我的传道标签</a:t>
             </a:r>
           </a:p>
           <a:p>
@@ -8451,7 +9927,7 @@
                 <a:ea typeface="PingFang SC"/>
                 <a:cs typeface="PingFang SC"/>
               </a:rPr>
-              <a:t>②  点当天日程</a:t>
+              <a:t>②  选“我的卡片”</a:t>
             </a:r>
           </a:p>
           <a:p>
@@ -8469,7 +9945,7 @@
                 <a:ea typeface="PingFang SC"/>
                 <a:cs typeface="PingFang SC"/>
               </a:rPr>
-              <a:t>③  “申请参与”（取消在同一处）</a:t>
+              <a:t>③  点卡片（地区）</a:t>
             </a:r>
           </a:p>
           <a:p>
@@ -8487,7 +9963,7 @@
                 <a:ea typeface="PingFang SC"/>
                 <a:cs typeface="PingFang SC"/>
               </a:rPr>
-              <a:t>💡 日程里也能看聊天·参加者。</a:t>
+              <a:t>💡 用上方筛选只看“需要探访”。</a:t>
             </a:r>
           </a:p>
         </p:txBody>
@@ -8535,6 +10011,7 @@
           <a:lstStyle/>
           <a:p>
             <a:pPr algn="ctr"/>
+            <a:endParaRPr/>
           </a:p>
         </p:txBody>
       </p:sp>
@@ -8555,7 +10032,7 @@
           <a:noFill/>
         </p:spPr>
         <p:txBody>
-          <a:bodyPr wrap="square" anchor="ctr" lIns="45720" rIns="45720" tIns="27432" bIns="27432">
+          <a:bodyPr wrap="square" lIns="45720" tIns="27432" rIns="45720" bIns="27432" anchor="ctr">
             <a:spAutoFit/>
           </a:bodyPr>
           <a:lstStyle/>
@@ -8596,7 +10073,7 @@
           <a:noFill/>
         </p:spPr>
         <p:txBody>
-          <a:bodyPr wrap="square" anchor="ctr" lIns="45720" rIns="45720" tIns="27432" bIns="27432">
+          <a:bodyPr wrap="square" lIns="45720" tIns="27432" rIns="45720" bIns="27432" anchor="ctr">
             <a:spAutoFit/>
           </a:bodyPr>
           <a:lstStyle/>
@@ -8615,381 +10092,41 @@
                 <a:ea typeface="PingFang SC"/>
                 <a:cs typeface="PingFang SC"/>
               </a:rPr>
-              <a:t>日程详情 + 申请按钮</a:t>
-            </a:r>
-          </a:p>
-        </p:txBody>
-      </p:sp>
-    </p:spTree>
-  </p:cSld>
-  <p:clrMapOvr>
-    <a:masterClrMapping/>
-  </p:clrMapOvr>
-</p:sld>
-</file>
-
-<file path=ppt/slides/slide9.xml><?xml version="1.0" encoding="utf-8"?>
-<p:sld xmlns:a="http://schemas.openxmlformats.org/drawingml/2006/main" xmlns:p="http://schemas.openxmlformats.org/presentationml/2006/main" xmlns:r="http://schemas.openxmlformats.org/officeDocument/2006/relationships">
-  <p:cSld>
-    <p:spTree>
-      <p:nvGrpSpPr>
-        <p:cNvPr id="1" name=""/>
-        <p:cNvGrpSpPr/>
-        <p:nvPr/>
-      </p:nvGrpSpPr>
-      <p:grpSpPr/>
-      <p:sp>
-        <p:nvSpPr>
-          <p:cNvPr id="2" name="Rectangle 1"/>
-          <p:cNvSpPr/>
-          <p:nvPr/>
-        </p:nvSpPr>
-        <p:spPr>
-          <a:xfrm>
-            <a:off x="0" y="0"/>
-            <a:ext cx="12191695" cy="6858000"/>
-          </a:xfrm>
-          <a:prstGeom prst="rect">
-            <a:avLst/>
-          </a:prstGeom>
-          <a:solidFill>
-            <a:srgbClr val="FFFFFF"/>
-          </a:solidFill>
-          <a:ln>
-            <a:noFill/>
-          </a:ln>
-          <a:effectLst/>
-        </p:spPr>
-        <p:style>
-          <a:lnRef idx="1">
-            <a:schemeClr val="accent1"/>
-          </a:lnRef>
-          <a:fillRef idx="3">
-            <a:schemeClr val="accent1"/>
-          </a:fillRef>
-          <a:effectRef idx="2">
-            <a:schemeClr val="accent1"/>
-          </a:effectRef>
-          <a:fontRef idx="minor">
-            <a:schemeClr val="lt1"/>
-          </a:fontRef>
-        </p:style>
-        <p:txBody>
-          <a:bodyPr rtlCol="0" anchor="ctr"/>
-          <a:lstStyle/>
-          <a:p>
-            <a:pPr algn="ctr"/>
-          </a:p>
-        </p:txBody>
-      </p:sp>
-      <p:sp>
-        <p:nvSpPr>
-          <p:cNvPr id="3" name="Rectangle 2"/>
-          <p:cNvSpPr/>
-          <p:nvPr/>
-        </p:nvSpPr>
-        <p:spPr>
-          <a:xfrm>
-            <a:off x="0" y="0"/>
-            <a:ext cx="201168" cy="1371600"/>
-          </a:xfrm>
-          <a:prstGeom prst="rect">
-            <a:avLst/>
-          </a:prstGeom>
-          <a:solidFill>
-            <a:srgbClr val="2D6A4F"/>
-          </a:solidFill>
-          <a:ln>
-            <a:noFill/>
-          </a:ln>
-          <a:effectLst/>
-        </p:spPr>
-        <p:style>
-          <a:lnRef idx="1">
-            <a:schemeClr val="accent1"/>
-          </a:lnRef>
-          <a:fillRef idx="3">
-            <a:schemeClr val="accent1"/>
-          </a:fillRef>
-          <a:effectRef idx="2">
-            <a:schemeClr val="accent1"/>
-          </a:effectRef>
-          <a:fontRef idx="minor">
-            <a:schemeClr val="lt1"/>
-          </a:fontRef>
-        </p:style>
-        <p:txBody>
-          <a:bodyPr rtlCol="0" anchor="ctr"/>
-          <a:lstStyle/>
-          <a:p>
-            <a:pPr algn="ctr"/>
-          </a:p>
-        </p:txBody>
-      </p:sp>
-      <p:sp>
-        <p:nvSpPr>
-          <p:cNvPr id="4" name="TextBox 3"/>
-          <p:cNvSpPr txBox="1"/>
-          <p:nvPr/>
-        </p:nvSpPr>
-        <p:spPr>
-          <a:xfrm>
-            <a:off x="548640" y="411480"/>
-            <a:ext cx="7315200" cy="914400"/>
-          </a:xfrm>
-          <a:prstGeom prst="rect">
-            <a:avLst/>
-          </a:prstGeom>
-          <a:noFill/>
-        </p:spPr>
-        <p:txBody>
-          <a:bodyPr wrap="square" anchor="t" lIns="45720" rIns="45720" tIns="27432" bIns="27432">
-            <a:spAutoFit/>
-          </a:bodyPr>
-          <a:lstStyle/>
-          <a:p>
-            <a:pPr algn="l">
-              <a:spcAft>
-                <a:spcPts val="600"/>
-              </a:spcAft>
-            </a:pPr>
-            <a:r>
-              <a:rPr sz="3000" b="1">
-                <a:solidFill>
-                  <a:srgbClr val="1C1C1A"/>
-                </a:solidFill>
-                <a:latin typeface="PingFang SC"/>
-                <a:ea typeface="PingFang SC"/>
-                <a:cs typeface="PingFang SC"/>
-              </a:rPr>
-              <a:t>【我的传道】① 查看我的地区</a:t>
-            </a:r>
-          </a:p>
-        </p:txBody>
-      </p:sp>
-      <p:sp>
-        <p:nvSpPr>
-          <p:cNvPr id="5" name="TextBox 4"/>
-          <p:cNvSpPr txBox="1"/>
-          <p:nvPr/>
-        </p:nvSpPr>
-        <p:spPr>
-          <a:xfrm>
-            <a:off x="594360" y="1645920"/>
-            <a:ext cx="6766560" cy="4754880"/>
-          </a:xfrm>
-          <a:prstGeom prst="rect">
-            <a:avLst/>
-          </a:prstGeom>
-          <a:noFill/>
-        </p:spPr>
-        <p:txBody>
-          <a:bodyPr wrap="square" anchor="t" lIns="45720" rIns="45720" tIns="27432" bIns="27432">
-            <a:spAutoFit/>
-          </a:bodyPr>
-          <a:lstStyle/>
-          <a:p>
-            <a:pPr algn="l">
-              <a:spcAft>
-                <a:spcPts val="1000"/>
-              </a:spcAft>
-            </a:pPr>
-            <a:r>
-              <a:rPr sz="1900" b="0">
-                <a:solidFill>
-                  <a:srgbClr val="1C1C1A"/>
-                </a:solidFill>
-                <a:latin typeface="PingFang SC"/>
-                <a:ea typeface="PingFang SC"/>
-                <a:cs typeface="PingFang SC"/>
-              </a:rPr>
-              <a:t>①  我的传道标签</a:t>
-            </a:r>
-          </a:p>
-          <a:p>
-            <a:pPr algn="l">
-              <a:spcAft>
-                <a:spcPts val="1000"/>
-              </a:spcAft>
-            </a:pPr>
-            <a:r>
-              <a:rPr sz="1900" b="0">
-                <a:solidFill>
-                  <a:srgbClr val="1C1C1A"/>
-                </a:solidFill>
-                <a:latin typeface="PingFang SC"/>
-                <a:ea typeface="PingFang SC"/>
-                <a:cs typeface="PingFang SC"/>
-              </a:rPr>
-              <a:t>②  选“我的卡片”</a:t>
-            </a:r>
-          </a:p>
-          <a:p>
-            <a:pPr algn="l">
-              <a:spcAft>
-                <a:spcPts val="1000"/>
-              </a:spcAft>
-            </a:pPr>
-            <a:r>
-              <a:rPr sz="1900" b="0">
-                <a:solidFill>
-                  <a:srgbClr val="1C1C1A"/>
-                </a:solidFill>
-                <a:latin typeface="PingFang SC"/>
-                <a:ea typeface="PingFang SC"/>
-                <a:cs typeface="PingFang SC"/>
-              </a:rPr>
-              <a:t>③  点卡片（地区）</a:t>
-            </a:r>
-          </a:p>
-          <a:p>
-            <a:pPr algn="l">
-              <a:spcAft>
-                <a:spcPts val="600"/>
-              </a:spcAft>
-            </a:pPr>
-            <a:r>
-              <a:rPr sz="1600" b="0">
-                <a:solidFill>
-                  <a:srgbClr val="B45A09"/>
-                </a:solidFill>
-                <a:latin typeface="PingFang SC"/>
-                <a:ea typeface="PingFang SC"/>
-                <a:cs typeface="PingFang SC"/>
-              </a:rPr>
-              <a:t>💡 用上方筛选只看“需要探访”。</a:t>
-            </a:r>
-          </a:p>
-        </p:txBody>
-      </p:sp>
-      <p:sp>
-        <p:nvSpPr>
-          <p:cNvPr id="6" name="Rounded Rectangle 5"/>
-          <p:cNvSpPr/>
-          <p:nvPr/>
-        </p:nvSpPr>
-        <p:spPr>
-          <a:xfrm>
-            <a:off x="7955279" y="1645920"/>
-            <a:ext cx="3566160" cy="4572000"/>
-          </a:xfrm>
-          <a:prstGeom prst="roundRect">
-            <a:avLst/>
-          </a:prstGeom>
-          <a:solidFill>
-            <a:srgbClr val="ECEEEC"/>
-          </a:solidFill>
-          <a:ln w="12700">
-            <a:solidFill>
-              <a:srgbClr val="C9CDC9"/>
-            </a:solidFill>
-          </a:ln>
-          <a:effectLst/>
-        </p:spPr>
-        <p:style>
-          <a:lnRef idx="1">
-            <a:schemeClr val="accent1"/>
-          </a:lnRef>
-          <a:fillRef idx="3">
-            <a:schemeClr val="accent1"/>
-          </a:fillRef>
-          <a:effectRef idx="2">
-            <a:schemeClr val="accent1"/>
-          </a:effectRef>
-          <a:fontRef idx="minor">
-            <a:schemeClr val="lt1"/>
-          </a:fontRef>
-        </p:style>
-        <p:txBody>
-          <a:bodyPr rtlCol="0" anchor="ctr"/>
-          <a:lstStyle/>
-          <a:p>
-            <a:pPr algn="ctr"/>
-          </a:p>
-        </p:txBody>
-      </p:sp>
-      <p:sp>
-        <p:nvSpPr>
-          <p:cNvPr id="7" name="TextBox 6"/>
-          <p:cNvSpPr txBox="1"/>
-          <p:nvPr/>
-        </p:nvSpPr>
-        <p:spPr>
-          <a:xfrm>
-            <a:off x="7955279" y="3657600"/>
-            <a:ext cx="3566160" cy="548640"/>
-          </a:xfrm>
-          <a:prstGeom prst="rect">
-            <a:avLst/>
-          </a:prstGeom>
-          <a:noFill/>
-        </p:spPr>
-        <p:txBody>
-          <a:bodyPr wrap="square" anchor="ctr" lIns="45720" rIns="45720" tIns="27432" bIns="27432">
-            <a:spAutoFit/>
-          </a:bodyPr>
-          <a:lstStyle/>
-          <a:p>
-            <a:pPr algn="ctr">
-              <a:spcAft>
-                <a:spcPts val="600"/>
-              </a:spcAft>
-            </a:pPr>
-            <a:r>
-              <a:rPr sz="1400" b="0">
-                <a:solidFill>
-                  <a:srgbClr val="6B7280"/>
-                </a:solidFill>
-                <a:latin typeface="PingFang SC"/>
-                <a:ea typeface="PingFang SC"/>
-                <a:cs typeface="PingFang SC"/>
-              </a:rPr>
-              <a:t>📷 放置截图</a:t>
-            </a:r>
-          </a:p>
-        </p:txBody>
-      </p:sp>
-      <p:sp>
-        <p:nvSpPr>
-          <p:cNvPr id="8" name="TextBox 7"/>
-          <p:cNvSpPr txBox="1"/>
-          <p:nvPr/>
-        </p:nvSpPr>
-        <p:spPr>
-          <a:xfrm>
-            <a:off x="7955279" y="4069080"/>
-            <a:ext cx="3566160" cy="457200"/>
-          </a:xfrm>
-          <a:prstGeom prst="rect">
-            <a:avLst/>
-          </a:prstGeom>
-          <a:noFill/>
-        </p:spPr>
-        <p:txBody>
-          <a:bodyPr wrap="square" anchor="ctr" lIns="45720" rIns="45720" tIns="27432" bIns="27432">
-            <a:spAutoFit/>
-          </a:bodyPr>
-          <a:lstStyle/>
-          <a:p>
-            <a:pPr algn="ctr">
-              <a:spcAft>
-                <a:spcPts val="600"/>
-              </a:spcAft>
-            </a:pPr>
-            <a:r>
-              <a:rPr sz="1100" b="0">
-                <a:solidFill>
-                  <a:srgbClr val="6B7280"/>
-                </a:solidFill>
-                <a:latin typeface="PingFang SC"/>
-                <a:ea typeface="PingFang SC"/>
-                <a:cs typeface="PingFang SC"/>
-              </a:rPr>
               <a:t>我的卡片列表</a:t>
             </a:r>
           </a:p>
         </p:txBody>
       </p:sp>
+      <p:pic>
+        <p:nvPicPr>
+          <p:cNvPr id="9" name="그림 8" descr="텍스트, 스크린샷, 폰트, 번호이(가) 표시된 사진&#10;&#10;AI 생성 콘텐츠는 정확하지 않을 수 있습니다.">
+            <a:extLst>
+              <a:ext uri="{FF2B5EF4-FFF2-40B4-BE49-F238E27FC236}">
+                <a16:creationId xmlns:a16="http://schemas.microsoft.com/office/drawing/2014/main" id="{95E222C9-FF73-4091-BA51-B25F5B6FDDED}"/>
+              </a:ext>
+            </a:extLst>
+          </p:cNvPr>
+          <p:cNvPicPr>
+            <a:picLocks noChangeAspect="1"/>
+          </p:cNvPicPr>
+          <p:nvPr/>
+        </p:nvPicPr>
+        <p:blipFill>
+          <a:blip r:embed="rId2"/>
+          <a:stretch>
+            <a:fillRect/>
+          </a:stretch>
+        </p:blipFill>
+        <p:spPr>
+          <a:xfrm>
+            <a:off x="7863840" y="0"/>
+            <a:ext cx="3718714" cy="6858000"/>
+          </a:xfrm>
+          <a:prstGeom prst="rect">
+            <a:avLst/>
+          </a:prstGeom>
+        </p:spPr>
+      </p:pic>
     </p:spTree>
   </p:cSld>
   <p:clrMapOvr>
@@ -9316,4 +10453,319 @@
   </a:objectDefaults>
   <a:extraClrSchemeLst/>
 </a:theme>
+</file>
+
+<file path=ppt/theme/theme2.xml><?xml version="1.0" encoding="utf-8"?>
+<a:theme xmlns:a="http://schemas.openxmlformats.org/drawingml/2006/main" name="Office 테마">
+  <a:themeElements>
+    <a:clrScheme name="Office">
+      <a:dk1>
+        <a:sysClr val="windowText" lastClr="000000"/>
+      </a:dk1>
+      <a:lt1>
+        <a:sysClr val="window" lastClr="FFFFFF"/>
+      </a:lt1>
+      <a:dk2>
+        <a:srgbClr val="0E2841"/>
+      </a:dk2>
+      <a:lt2>
+        <a:srgbClr val="E8E8E8"/>
+      </a:lt2>
+      <a:accent1>
+        <a:srgbClr val="156082"/>
+      </a:accent1>
+      <a:accent2>
+        <a:srgbClr val="E97132"/>
+      </a:accent2>
+      <a:accent3>
+        <a:srgbClr val="196B24"/>
+      </a:accent3>
+      <a:accent4>
+        <a:srgbClr val="0F9ED5"/>
+      </a:accent4>
+      <a:accent5>
+        <a:srgbClr val="A02B93"/>
+      </a:accent5>
+      <a:accent6>
+        <a:srgbClr val="4EA72E"/>
+      </a:accent6>
+      <a:hlink>
+        <a:srgbClr val="467886"/>
+      </a:hlink>
+      <a:folHlink>
+        <a:srgbClr val="96607D"/>
+      </a:folHlink>
+    </a:clrScheme>
+    <a:fontScheme name="Office">
+      <a:majorFont>
+        <a:latin typeface="Aptos Display" panose="02110004020202020204"/>
+        <a:ea typeface=""/>
+        <a:cs typeface=""/>
+        <a:font script="Jpan" typeface="游ゴシック Light"/>
+        <a:font script="Hang" typeface="맑은 고딕"/>
+        <a:font script="Hans" typeface="等线 Light"/>
+        <a:font script="Hant" typeface="新細明體"/>
+        <a:font script="Arab" typeface="Times New Roman"/>
+        <a:font script="Hebr" typeface="Times New Roman"/>
+        <a:font script="Thai" typeface="Angsana New"/>
+        <a:font script="Ethi" typeface="Nyala"/>
+        <a:font script="Beng" typeface="Vrinda"/>
+        <a:font script="Gujr" typeface="Shruti"/>
+        <a:font script="Khmr" typeface="MoolBoran"/>
+        <a:font script="Knda" typeface="Tunga"/>
+        <a:font script="Guru" typeface="Raavi"/>
+        <a:font script="Cans" typeface="Euphemia"/>
+        <a:font script="Cher" typeface="Plantagenet Cherokee"/>
+        <a:font script="Yiii" typeface="Microsoft Yi Baiti"/>
+        <a:font script="Tibt" typeface="Microsoft Himalaya"/>
+        <a:font script="Thaa" typeface="MV Boli"/>
+        <a:font script="Deva" typeface="Mangal"/>
+        <a:font script="Telu" typeface="Gautami"/>
+        <a:font script="Taml" typeface="Latha"/>
+        <a:font script="Syrc" typeface="Estrangelo Edessa"/>
+        <a:font script="Orya" typeface="Kalinga"/>
+        <a:font script="Mlym" typeface="Kartika"/>
+        <a:font script="Laoo" typeface="DokChampa"/>
+        <a:font script="Sinh" typeface="Iskoola Pota"/>
+        <a:font script="Mong" typeface="Mongolian Baiti"/>
+        <a:font script="Viet" typeface="Times New Roman"/>
+        <a:font script="Uigh" typeface="Microsoft Uighur"/>
+        <a:font script="Geor" typeface="Sylfaen"/>
+        <a:font script="Armn" typeface="Arial"/>
+        <a:font script="Bugi" typeface="Leelawadee UI"/>
+        <a:font script="Bopo" typeface="Microsoft JhengHei"/>
+        <a:font script="Java" typeface="Javanese Text"/>
+        <a:font script="Lisu" typeface="Segoe UI"/>
+        <a:font script="Mymr" typeface="Myanmar Text"/>
+        <a:font script="Nkoo" typeface="Ebrima"/>
+        <a:font script="Olck" typeface="Nirmala UI"/>
+        <a:font script="Osma" typeface="Ebrima"/>
+        <a:font script="Phag" typeface="Phagspa"/>
+        <a:font script="Syrn" typeface="Estrangelo Edessa"/>
+        <a:font script="Syrj" typeface="Estrangelo Edessa"/>
+        <a:font script="Syre" typeface="Estrangelo Edessa"/>
+        <a:font script="Sora" typeface="Nirmala UI"/>
+        <a:font script="Tale" typeface="Microsoft Tai Le"/>
+        <a:font script="Talu" typeface="Microsoft New Tai Lue"/>
+        <a:font script="Tfng" typeface="Ebrima"/>
+      </a:majorFont>
+      <a:minorFont>
+        <a:latin typeface="Aptos" panose="02110004020202020204"/>
+        <a:ea typeface=""/>
+        <a:cs typeface=""/>
+        <a:font script="Jpan" typeface="游ゴシック"/>
+        <a:font script="Hang" typeface="맑은 고딕"/>
+        <a:font script="Hans" typeface="等线"/>
+        <a:font script="Hant" typeface="新細明體"/>
+        <a:font script="Arab" typeface="Arial"/>
+        <a:font script="Hebr" typeface="Arial"/>
+        <a:font script="Thai" typeface="Cordia New"/>
+        <a:font script="Ethi" typeface="Nyala"/>
+        <a:font script="Beng" typeface="Vrinda"/>
+        <a:font script="Gujr" typeface="Shruti"/>
+        <a:font script="Khmr" typeface="DaunPenh"/>
+        <a:font script="Knda" typeface="Tunga"/>
+        <a:font script="Guru" typeface="Raavi"/>
+        <a:font script="Cans" typeface="Euphemia"/>
+        <a:font script="Cher" typeface="Plantagenet Cherokee"/>
+        <a:font script="Yiii" typeface="Microsoft Yi Baiti"/>
+        <a:font script="Tibt" typeface="Microsoft Himalaya"/>
+        <a:font script="Thaa" typeface="MV Boli"/>
+        <a:font script="Deva" typeface="Mangal"/>
+        <a:font script="Telu" typeface="Gautami"/>
+        <a:font script="Taml" typeface="Latha"/>
+        <a:font script="Syrc" typeface="Estrangelo Edessa"/>
+        <a:font script="Orya" typeface="Kalinga"/>
+        <a:font script="Mlym" typeface="Kartika"/>
+        <a:font script="Laoo" typeface="DokChampa"/>
+        <a:font script="Sinh" typeface="Iskoola Pota"/>
+        <a:font script="Mong" typeface="Mongolian Baiti"/>
+        <a:font script="Viet" typeface="Arial"/>
+        <a:font script="Uigh" typeface="Microsoft Uighur"/>
+        <a:font script="Geor" typeface="Sylfaen"/>
+        <a:font script="Armn" typeface="Arial"/>
+        <a:font script="Bugi" typeface="Leelawadee UI"/>
+        <a:font script="Bopo" typeface="Microsoft JhengHei"/>
+        <a:font script="Java" typeface="Javanese Text"/>
+        <a:font script="Lisu" typeface="Segoe UI"/>
+        <a:font script="Mymr" typeface="Myanmar Text"/>
+        <a:font script="Nkoo" typeface="Ebrima"/>
+        <a:font script="Olck" typeface="Nirmala UI"/>
+        <a:font script="Osma" typeface="Ebrima"/>
+        <a:font script="Phag" typeface="Phagspa"/>
+        <a:font script="Syrn" typeface="Estrangelo Edessa"/>
+        <a:font script="Syrj" typeface="Estrangelo Edessa"/>
+        <a:font script="Syre" typeface="Estrangelo Edessa"/>
+        <a:font script="Sora" typeface="Nirmala UI"/>
+        <a:font script="Tale" typeface="Microsoft Tai Le"/>
+        <a:font script="Talu" typeface="Microsoft New Tai Lue"/>
+        <a:font script="Tfng" typeface="Ebrima"/>
+      </a:minorFont>
+    </a:fontScheme>
+    <a:fmtScheme name="Office">
+      <a:fillStyleLst>
+        <a:solidFill>
+          <a:schemeClr val="phClr"/>
+        </a:solidFill>
+        <a:gradFill rotWithShape="1">
+          <a:gsLst>
+            <a:gs pos="0">
+              <a:schemeClr val="phClr">
+                <a:lumMod val="110000"/>
+                <a:satMod val="105000"/>
+                <a:tint val="67000"/>
+              </a:schemeClr>
+            </a:gs>
+            <a:gs pos="50000">
+              <a:schemeClr val="phClr">
+                <a:lumMod val="105000"/>
+                <a:satMod val="103000"/>
+                <a:tint val="73000"/>
+              </a:schemeClr>
+            </a:gs>
+            <a:gs pos="100000">
+              <a:schemeClr val="phClr">
+                <a:lumMod val="105000"/>
+                <a:satMod val="109000"/>
+                <a:tint val="81000"/>
+              </a:schemeClr>
+            </a:gs>
+          </a:gsLst>
+          <a:lin ang="5400000" scaled="0"/>
+        </a:gradFill>
+        <a:gradFill rotWithShape="1">
+          <a:gsLst>
+            <a:gs pos="0">
+              <a:schemeClr val="phClr">
+                <a:satMod val="103000"/>
+                <a:lumMod val="102000"/>
+                <a:tint val="94000"/>
+              </a:schemeClr>
+            </a:gs>
+            <a:gs pos="50000">
+              <a:schemeClr val="phClr">
+                <a:satMod val="110000"/>
+                <a:lumMod val="100000"/>
+                <a:shade val="100000"/>
+              </a:schemeClr>
+            </a:gs>
+            <a:gs pos="100000">
+              <a:schemeClr val="phClr">
+                <a:lumMod val="99000"/>
+                <a:satMod val="120000"/>
+                <a:shade val="78000"/>
+              </a:schemeClr>
+            </a:gs>
+          </a:gsLst>
+          <a:lin ang="5400000" scaled="0"/>
+        </a:gradFill>
+      </a:fillStyleLst>
+      <a:lnStyleLst>
+        <a:ln w="12700" cap="flat" cmpd="sng" algn="ctr">
+          <a:solidFill>
+            <a:schemeClr val="phClr"/>
+          </a:solidFill>
+          <a:prstDash val="solid"/>
+          <a:miter lim="800000"/>
+        </a:ln>
+        <a:ln w="19050" cap="flat" cmpd="sng" algn="ctr">
+          <a:solidFill>
+            <a:schemeClr val="phClr"/>
+          </a:solidFill>
+          <a:prstDash val="solid"/>
+          <a:miter lim="800000"/>
+        </a:ln>
+        <a:ln w="25400" cap="flat" cmpd="sng" algn="ctr">
+          <a:solidFill>
+            <a:schemeClr val="phClr"/>
+          </a:solidFill>
+          <a:prstDash val="solid"/>
+          <a:miter lim="800000"/>
+        </a:ln>
+      </a:lnStyleLst>
+      <a:effectStyleLst>
+        <a:effectStyle>
+          <a:effectLst/>
+        </a:effectStyle>
+        <a:effectStyle>
+          <a:effectLst/>
+        </a:effectStyle>
+        <a:effectStyle>
+          <a:effectLst>
+            <a:outerShdw blurRad="57150" dist="19050" dir="5400000" algn="ctr" rotWithShape="0">
+              <a:srgbClr val="000000">
+                <a:alpha val="63000"/>
+              </a:srgbClr>
+            </a:outerShdw>
+          </a:effectLst>
+        </a:effectStyle>
+      </a:effectStyleLst>
+      <a:bgFillStyleLst>
+        <a:solidFill>
+          <a:schemeClr val="phClr"/>
+        </a:solidFill>
+        <a:solidFill>
+          <a:schemeClr val="phClr">
+            <a:tint val="95000"/>
+            <a:satMod val="170000"/>
+          </a:schemeClr>
+        </a:solidFill>
+        <a:gradFill rotWithShape="1">
+          <a:gsLst>
+            <a:gs pos="0">
+              <a:schemeClr val="phClr">
+                <a:tint val="93000"/>
+                <a:satMod val="150000"/>
+                <a:shade val="98000"/>
+                <a:lumMod val="102000"/>
+              </a:schemeClr>
+            </a:gs>
+            <a:gs pos="50000">
+              <a:schemeClr val="phClr">
+                <a:tint val="98000"/>
+                <a:satMod val="130000"/>
+                <a:shade val="90000"/>
+                <a:lumMod val="103000"/>
+              </a:schemeClr>
+            </a:gs>
+            <a:gs pos="100000">
+              <a:schemeClr val="phClr">
+                <a:shade val="63000"/>
+                <a:satMod val="120000"/>
+              </a:schemeClr>
+            </a:gs>
+          </a:gsLst>
+          <a:lin ang="5400000" scaled="0"/>
+        </a:gradFill>
+      </a:bgFillStyleLst>
+    </a:fmtScheme>
+  </a:themeElements>
+  <a:objectDefaults>
+    <a:lnDef>
+      <a:spPr/>
+      <a:bodyPr/>
+      <a:lstStyle/>
+      <a:style>
+        <a:lnRef idx="2">
+          <a:schemeClr val="accent1"/>
+        </a:lnRef>
+        <a:fillRef idx="0">
+          <a:schemeClr val="accent1"/>
+        </a:fillRef>
+        <a:effectRef idx="1">
+          <a:schemeClr val="accent1"/>
+        </a:effectRef>
+        <a:fontRef idx="minor">
+          <a:schemeClr val="tx1"/>
+        </a:fontRef>
+      </a:style>
+    </a:lnDef>
+  </a:objectDefaults>
+  <a:extraClrSchemeLst/>
+  <a:extLst>
+    <a:ext uri="{05A4C25C-085E-4340-85A3-A5531E510DB2}">
+      <thm15:themeFamily xmlns:thm15="http://schemas.microsoft.com/office/thememl/2012/main" name="Office Theme" id="{2E142A2C-CD16-42D6-873A-C26D2A0506FA}" vid="{1BDDFF52-6CD6-40A5-AB3C-68EB2F1E4D0A}"/>
+    </a:ext>
+  </a:extLst>
+</a:theme>
 </file>
</xml_diff>